<commit_message>
S3: integrar logo oficial UNAB a color con badge de contraste para portada y diapositivas
</commit_message>
<xml_diff>
--- a/S3/informe/Presentacion_Bloque4_Sebastian.pptx
+++ b/S3/informe/Presentacion_Bloque4_Sebastian.pptx
@@ -3892,9 +3892,52 @@
           </a:p>
         </p:txBody>
       </p:sp>
+      <p:sp>
+        <p:nvSpPr>
+          <p:cNvPr id="3" name="Rounded Rectangle 2"/>
+          <p:cNvSpPr/>
+          <p:nvPr/>
+        </p:nvSpPr>
+        <p:spPr>
+          <a:xfrm>
+            <a:off x="914400" y="822960"/>
+            <a:ext cx="2011680" cy="1371600"/>
+          </a:xfrm>
+          <a:prstGeom prst="roundRect">
+            <a:avLst/>
+          </a:prstGeom>
+          <a:solidFill>
+            <a:srgbClr val="FFFFFF"/>
+          </a:solidFill>
+          <a:ln>
+            <a:noFill/>
+          </a:ln>
+        </p:spPr>
+        <p:style>
+          <a:lnRef idx="1">
+            <a:schemeClr val="accent1"/>
+          </a:lnRef>
+          <a:fillRef idx="3">
+            <a:schemeClr val="accent1"/>
+          </a:fillRef>
+          <a:effectRef idx="2">
+            <a:schemeClr val="accent1"/>
+          </a:effectRef>
+          <a:fontRef idx="minor">
+            <a:schemeClr val="lt1"/>
+          </a:fontRef>
+        </p:style>
+        <p:txBody>
+          <a:bodyPr rtlCol="0" anchor="ctr"/>
+          <a:lstStyle/>
+          <a:p>
+            <a:pPr algn="ctr"/>
+          </a:p>
+        </p:txBody>
+      </p:sp>
       <p:pic>
         <p:nvPicPr>
-          <p:cNvPr id="3" name="Picture 2" descr="logo_unab.png"/>
+          <p:cNvPr id="4" name="Picture 3" descr="logo_unab_color.png"/>
           <p:cNvPicPr>
             <a:picLocks noChangeAspect="1"/>
           </p:cNvPicPr>
@@ -3908,8 +3951,8 @@
         </p:blipFill>
         <p:spPr>
           <a:xfrm>
-            <a:off x="914400" y="914400"/>
-            <a:ext cx="1324096" cy="1097280"/>
+            <a:off x="1097280" y="914400"/>
+            <a:ext cx="1413762" cy="1188720"/>
           </a:xfrm>
           <a:prstGeom prst="rect">
             <a:avLst/>
@@ -3918,14 +3961,14 @@
       </p:pic>
       <p:sp>
         <p:nvSpPr>
-          <p:cNvPr id="4" name="TextBox 3"/>
+          <p:cNvPr id="5" name="TextBox 4"/>
           <p:cNvSpPr txBox="1"/>
           <p:nvPr/>
         </p:nvSpPr>
         <p:spPr>
           <a:xfrm>
-            <a:off x="914400" y="2286000"/>
-            <a:ext cx="10332720" cy="457200"/>
+            <a:off x="914400" y="2423160"/>
+            <a:ext cx="10332720" cy="365760"/>
           </a:xfrm>
           <a:prstGeom prst="rect">
             <a:avLst/>
@@ -3953,13 +3996,13 @@
       </p:sp>
       <p:sp>
         <p:nvSpPr>
-          <p:cNvPr id="5" name="TextBox 4"/>
+          <p:cNvPr id="6" name="TextBox 5"/>
           <p:cNvSpPr txBox="1"/>
           <p:nvPr/>
         </p:nvSpPr>
         <p:spPr>
           <a:xfrm>
-            <a:off x="914400" y="2743200"/>
+            <a:off x="914400" y="2834640"/>
             <a:ext cx="10332720" cy="1463040"/>
           </a:xfrm>
           <a:prstGeom prst="rect">
@@ -3992,14 +4035,14 @@
       </p:sp>
       <p:sp>
         <p:nvSpPr>
-          <p:cNvPr id="6" name="TextBox 5"/>
+          <p:cNvPr id="7" name="TextBox 6"/>
           <p:cNvSpPr txBox="1"/>
           <p:nvPr/>
         </p:nvSpPr>
         <p:spPr>
           <a:xfrm>
-            <a:off x="914400" y="4389120"/>
-            <a:ext cx="10332720" cy="731520"/>
+            <a:off x="914400" y="4434840"/>
+            <a:ext cx="10332720" cy="548640"/>
           </a:xfrm>
           <a:prstGeom prst="rect">
             <a:avLst/>
@@ -4027,14 +4070,14 @@
       </p:sp>
       <p:sp>
         <p:nvSpPr>
-          <p:cNvPr id="7" name="TextBox 6"/>
+          <p:cNvPr id="8" name="TextBox 7"/>
           <p:cNvSpPr txBox="1"/>
           <p:nvPr/>
         </p:nvSpPr>
         <p:spPr>
           <a:xfrm>
-            <a:off x="914400" y="5212080"/>
-            <a:ext cx="10332720" cy="1097280"/>
+            <a:off x="914400" y="5166360"/>
+            <a:ext cx="10332720" cy="1188720"/>
           </a:xfrm>
           <a:prstGeom prst="rect">
             <a:avLst/>
@@ -4134,7 +4177,7 @@
         <p:spPr>
           <a:xfrm>
             <a:off x="731520" y="640080"/>
-            <a:ext cx="9601200" cy="731520"/>
+            <a:ext cx="9326880" cy="731520"/>
           </a:xfrm>
           <a:prstGeom prst="rect">
             <a:avLst/>
@@ -4162,7 +4205,7 @@
       </p:sp>
       <p:pic>
         <p:nvPicPr>
-          <p:cNvPr id="4" name="Picture 3" descr="logo_unab.png"/>
+          <p:cNvPr id="4" name="Picture 3" descr="logo_unab_color.png"/>
           <p:cNvPicPr>
             <a:picLocks noChangeAspect="1"/>
           </p:cNvPicPr>
@@ -4176,8 +4219,8 @@
         </p:blipFill>
         <p:spPr>
           <a:xfrm>
-            <a:off x="10241280" y="365760"/>
-            <a:ext cx="882731" cy="731520"/>
+            <a:off x="10332720" y="320040"/>
+            <a:ext cx="1033134" cy="868680"/>
           </a:xfrm>
           <a:prstGeom prst="rect">
             <a:avLst/>
@@ -4514,7 +4557,7 @@
         <p:spPr>
           <a:xfrm>
             <a:off x="731520" y="640080"/>
-            <a:ext cx="9601200" cy="731520"/>
+            <a:ext cx="9326880" cy="731520"/>
           </a:xfrm>
           <a:prstGeom prst="rect">
             <a:avLst/>
@@ -4542,7 +4585,7 @@
       </p:sp>
       <p:pic>
         <p:nvPicPr>
-          <p:cNvPr id="4" name="Picture 3" descr="logo_unab.png"/>
+          <p:cNvPr id="4" name="Picture 3" descr="logo_unab_color.png"/>
           <p:cNvPicPr>
             <a:picLocks noChangeAspect="1"/>
           </p:cNvPicPr>
@@ -4556,8 +4599,8 @@
         </p:blipFill>
         <p:spPr>
           <a:xfrm>
-            <a:off x="10241280" y="365760"/>
-            <a:ext cx="882731" cy="731520"/>
+            <a:off x="10332720" y="320040"/>
+            <a:ext cx="1033134" cy="868680"/>
           </a:xfrm>
           <a:prstGeom prst="rect">
             <a:avLst/>
@@ -5067,7 +5110,7 @@
         <p:spPr>
           <a:xfrm>
             <a:off x="731520" y="640080"/>
-            <a:ext cx="9601200" cy="731520"/>
+            <a:ext cx="9326880" cy="731520"/>
           </a:xfrm>
           <a:prstGeom prst="rect">
             <a:avLst/>
@@ -5095,7 +5138,7 @@
       </p:sp>
       <p:pic>
         <p:nvPicPr>
-          <p:cNvPr id="4" name="Picture 3" descr="logo_unab.png"/>
+          <p:cNvPr id="4" name="Picture 3" descr="logo_unab_color.png"/>
           <p:cNvPicPr>
             <a:picLocks noChangeAspect="1"/>
           </p:cNvPicPr>
@@ -5109,8 +5152,8 @@
         </p:blipFill>
         <p:spPr>
           <a:xfrm>
-            <a:off x="10241280" y="365760"/>
-            <a:ext cx="882731" cy="731520"/>
+            <a:off x="10332720" y="320040"/>
+            <a:ext cx="1033134" cy="868680"/>
           </a:xfrm>
           <a:prstGeom prst="rect">
             <a:avLst/>
@@ -5485,7 +5528,7 @@
         <p:spPr>
           <a:xfrm>
             <a:off x="731520" y="640080"/>
-            <a:ext cx="9601200" cy="731520"/>
+            <a:ext cx="9326880" cy="731520"/>
           </a:xfrm>
           <a:prstGeom prst="rect">
             <a:avLst/>
@@ -5513,7 +5556,7 @@
       </p:sp>
       <p:pic>
         <p:nvPicPr>
-          <p:cNvPr id="4" name="Picture 3" descr="logo_unab.png"/>
+          <p:cNvPr id="4" name="Picture 3" descr="logo_unab_color.png"/>
           <p:cNvPicPr>
             <a:picLocks noChangeAspect="1"/>
           </p:cNvPicPr>
@@ -5527,8 +5570,8 @@
         </p:blipFill>
         <p:spPr>
           <a:xfrm>
-            <a:off x="10241280" y="365760"/>
-            <a:ext cx="882731" cy="731520"/>
+            <a:off x="10332720" y="320040"/>
+            <a:ext cx="1033134" cy="868680"/>
           </a:xfrm>
           <a:prstGeom prst="rect">
             <a:avLst/>

</xml_diff>

<commit_message>
feat(s3): integracion final del informe sumativa 3, presentacion bloque 4 y guion con cifras auditadas
</commit_message>
<xml_diff>
--- a/S3/informe/Presentacion_Bloque4_Sebastian.pptx
+++ b/S3/informe/Presentacion_Bloque4_Sebastian.pptx
@@ -506,7 +506,7 @@
           <a:lstStyle/>
           <a:p>
             <a:r>
-              <a:t>Introducción al Bloque 4. Esperar el pase de César Lorca. Agradecer cordialmente e iniciar con seguridad técnica.</a:t>
+              <a:t>Muchas gracias, César. Para dar inicio al Bloque 4, abordaremos la validación de estabilidad mediante remuestreo bootstrap, el análisis comparativo del impacto de la imputación sobre el modelo final, y cerraremos con la síntesis acumulativa del proyecto y las recomendaciones estratégicas para la toma de decisiones.</a:t>
             </a:r>
           </a:p>
         </p:txBody>
@@ -576,19 +576,7 @@
           <a:lstStyle/>
           <a:p>
             <a:r>
-              <a:t>Muchas gracias, César. Para garantizar que nuestro modelo logístico final no dependa exclusivamente de supuestos asintóticos teóricos que suelen fallar en muestras con agrupamiento o asimetría —como detectamos en la Sumativa 2 mediante Jackknife—, aplicamos un remuestreo bootstrap no paramétrico con 1.000 réplicas sobre el conjunto de entrenamiento.</a:t>
-            </a:r>
-          </a:p>
-          <a:p/>
-          <a:p>
-            <a:r>
-              <a:t>Al contrastar los intervalos asintóticos tradicionales de Wald con los intervalos bootstrap percentil y BCa al 95 %, confirmamos una alta estabilidad paramétrica: los coeficientes de las variables de mayor impacto —como la jornada vespertina, la edad de titulación y las áreas tecnológicas— mantienen intervalos estrechos y sin cruzar el valor nulo de Odds Ratio igual a 1.</a:t>
-            </a:r>
-          </a:p>
-          <a:p/>
-          <a:p>
-            <a:r>
-              <a:t>Asimismo, el diagnóstico de supuestos ratificó la validez del modelo: los Factores de Inflación de Varianza se ubicaron bajo el umbral de 5 descartando multicolinealidad, la linealidad en el logit fue consistente según Box-Tidwell y no se identificaron puntos de apalancamiento que distorsionaran sustantivamente las probabilidades estimadas.</a:t>
+              <a:t>Muchas gracias, César. Para garantizar que nuestro modelo logístico final no dependa exclusivamente de supuestos asintóticos teóricos que suelen fallar en muestras con agrupamiento o asimetría —como detectamos en la Sumativa 2 mediante Jackknife—, aplicamos un remuestreo bootstrap no paramétrico con 1.000 réplicas por conglomerados institucionales. Al contrastar los intervalos tradicionales de Wald con los empíricos de Bootstrap al 95 %, confirmamos una alta estabilidad paramétrica: los coeficientes estructurales mantienen intervalos estrechos y sin cruzar el valor nulo de Odds Ratio igual a 1. Sin embargo, los intervalos se ensanchan entre 3,5 y 9,2 veces respecto a Wald, lo que prueba empíricamente que la dependencia institucional domina ampliamente la verdadera variabilidad.</a:t>
             </a:r>
           </a:p>
         </p:txBody>
@@ -658,19 +646,7 @@
           <a:lstStyle/>
           <a:p>
             <a:r>
-              <a:t>Uno de los focos evaluativos más relevantes de esta Sumativa 3 fue evaluar si la estrategia para tratar el 12,75 % de datos no observados altera o no las decisiones institucionales.</a:t>
-            </a:r>
-          </a:p>
-          <a:p/>
-          <a:p>
-            <a:r>
-              <a:t>Para responder a esto, re-ajustamos la especificación del modelo final sobre los tres escenarios: eliminación de casos completos, imputación simple por mediana e imputación por regresión múltiple.</a:t>
-            </a:r>
-          </a:p>
-          <a:p/>
-          <a:p>
-            <a:r>
-              <a:t>Los resultados son categóricos: aunque la eliminación de casos completos preserva la dirección general de los efectos, la imputación por regresión maximiza la potencia estadística sin inflar artificialmente la precisión, logrando un desempeño predictivo sólido en el conjunto de prueba, demostrando que los factores de riesgo identificados son estructurales y no un artefacto de la falta de datos.</a:t>
+              <a:t>La pregunta central de esta fase era: ¿cambia la decisión del negocio según cómo tratamos el 12,75 % de datos no observados? Evaluamos los modelos sobre una prueba común de 27.508 titulados con atraso estrictamente observado. Los resultados son categóricos: Primero, la imputación simple por mediana es inadmisible: invierte el signo de 3 jornadas y sobrestima la prevalencia en más de 3 puntos porcentuales. Segundo, al analizar nuestra imputación por regresión, identificamos un fenómeno crucial de la literatura estadística: una imputación no congeniada. Al haber omitido la jornada en el modelo lineal, se asignó una tasa plana de atraso a todas las modalidades, distorsionando los Odds Ratios de Diurna y Semipresencial. Para resolverlo, implementamos una Imputación Múltiple Congeniada con 20 réplicas y reglas de Rubin, reduciendo la distorsión media al 7,3 %, recuperando la calibración y alcanzando un AUC de 0,662 y exactitud de 65,3 %.</a:t>
             </a:r>
           </a:p>
         </p:txBody>
@@ -740,22 +716,7 @@
           <a:lstStyle/>
           <a:p>
             <a:r>
-              <a:t>Para concluir la exposición grupal, queremos destacar la progresión metodológica integral de este proyecto:</a:t>
-            </a:r>
-          </a:p>
-          <a:p>
-            <a:r>
-              <a:t>En S1, el análisis exploratorio evitó descartar erróneamente los valores atípicos y caracterizó la asimetría del rezago.</a:t>
-            </a:r>
-          </a:p>
-          <a:p>
-            <a:r>
-              <a:t>En S2, los métodos computacionales de remuestreo demostraron que la brecha de género se explicaba por el área de estudio y que existía una fuerte dependencia institucional.</a:t>
-            </a:r>
-          </a:p>
-          <a:p>
-            <a:r>
-              <a:t>Y en esta S3, integramos ambos antecedentes para imputar con fundamento teórico y construir un clasificador logístico robusto y validado computacionalmente.</a:t>
+              <a:t>Para concluir la exposición grupal, queremos destacar la progresión metodológica integral de este proyecto: En S1, el análisis exploratorio evitó descartar erróneamente los valores atípicos y caracterizó la asimetría del rezago. En S2, los métodos computacionales de remuestreo demostraron que la brecha de género se explicaba por el área de estudio y que existía una fuerte dependencia institucional. Y en esta S3, integramos ambos antecedentes para imputar con fundamento teórico, seleccionar covariables y construir un clasificador logístico robusto. En términos de negocio y política educativa, nuestras dos recomendaciones clave son: Primero, diseñar Sistemas de Alerta Temprana focalizados en facultades críticas de Derecho e Ingeniería. Y segundo, flexibilizar los plazos rígidos de gratuidad, considerando que el atraso severo es un fenómeno estructural del sistema universitario chileno. Muchas gracias por su atención y quedamos atentos a sus preguntas.</a:t>
             </a:r>
           </a:p>
         </p:txBody>
@@ -825,25 +786,7 @@
           <a:lstStyle/>
           <a:p>
             <a:r>
-              <a:t>En términos de negocio y política educativa, nuestras dos recomendaciones clave son:</a:t>
-            </a:r>
-          </a:p>
-          <a:p/>
-          <a:p>
-            <a:r>
-              <a:t>Primero, diseñar Sistemas de Alerta Temprana focalizados, donde las tutorías y el seguimiento académico se concentren de manera prioritaria en facultades de Ingeniería y Tecnología, con especial flexibilidad para los estudiantes de jornada vespertina.</a:t>
-            </a:r>
-          </a:p>
-          <a:p/>
-          <a:p>
-            <a:r>
-              <a:t>Y segundo, revisar los plazos rígidos de financiamiento y gratuidad, considerando que el atraso superior a 4 semestres no es una anomalía individual aislada, sino un fenómeno estructural del sistema formativo universitario chileno.</a:t>
-            </a:r>
-          </a:p>
-          <a:p/>
-          <a:p>
-            <a:r>
-              <a:t>Muchas gracias por su atención y quedamos atentos a sus preguntas.</a:t>
+              <a:t>Todo el pipeline computacional, los datos limpios y los notebooks ejecutados de las tres etapas están alojados de forma reproducible en nuestro repositorio oficial de GitHub. Agradecemos su atención y quedamos a su entera disposición para la ronda de preguntas.</a:t>
             </a:r>
           </a:p>
         </p:txBody>
@@ -3864,7 +3807,7 @@
             <a:avLst/>
           </a:prstGeom>
           <a:solidFill>
-            <a:srgbClr val="121E31"/>
+            <a:srgbClr val="0F2043"/>
           </a:solidFill>
           <a:ln>
             <a:noFill/>
@@ -3894,14 +3837,106 @@
       </p:sp>
       <p:sp>
         <p:nvSpPr>
-          <p:cNvPr id="3" name="Rounded Rectangle 2"/>
+          <p:cNvPr id="3" name="TextBox 2"/>
+          <p:cNvSpPr txBox="1"/>
+          <p:nvPr/>
+        </p:nvSpPr>
+        <p:spPr>
+          <a:xfrm>
+            <a:off x="731520" y="1097280"/>
+            <a:ext cx="7315200" cy="5029200"/>
+          </a:xfrm>
+          <a:prstGeom prst="rect">
+            <a:avLst/>
+          </a:prstGeom>
+          <a:noFill/>
+        </p:spPr>
+        <p:txBody>
+          <a:bodyPr wrap="square" lIns="0" tIns="0" rIns="0" bIns="0">
+            <a:spAutoFit/>
+          </a:bodyPr>
+          <a:lstStyle/>
+          <a:p>
+            <a:pPr>
+              <a:defRPr sz="1200" b="1">
+                <a:solidFill>
+                  <a:srgbClr val="93C5FD"/>
+                </a:solidFill>
+              </a:defRPr>
+            </a:pPr>
+            <a:r>
+              <a:t>EVALUACIÓN SUMATIVA 3: FASE 4 · CIERRE DEL PROYECTO</a:t>
+            </a:r>
+          </a:p>
+          <a:p>
+            <a:pPr>
+              <a:spcBef>
+                <a:spcPts val="1000"/>
+              </a:spcBef>
+              <a:defRPr sz="2800" b="1">
+                <a:solidFill>
+                  <a:srgbClr val="FFFFFF"/>
+                </a:solidFill>
+              </a:defRPr>
+            </a:pPr>
+            <a:r>
+              <a:t>Modelamiento Predictivo Integrado del Atraso Académico en Educación Superior</a:t>
+            </a:r>
+          </a:p>
+          <a:p>
+            <a:pPr>
+              <a:spcBef>
+                <a:spcPts val="1200"/>
+              </a:spcBef>
+              <a:defRPr sz="1600">
+                <a:solidFill>
+                  <a:srgbClr val="E2E8F0"/>
+                </a:solidFill>
+              </a:defRPr>
+            </a:pPr>
+            <a:r>
+              <a:t>Bloque 4: Estabilidad Bootstrap, Impacto de la Imputación y Recomendaciones Estratégicas</a:t>
+            </a:r>
+          </a:p>
+          <a:p>
+            <a:pPr>
+              <a:spcBef>
+                <a:spcPts val="2400"/>
+              </a:spcBef>
+              <a:defRPr sz="1200">
+                <a:solidFill>
+                  <a:srgbClr val="94A3B8"/>
+                </a:solidFill>
+              </a:defRPr>
+            </a:pPr>
+            <a:r>
+              <a:t>• Expositor Bloque 4: Sebastián Cajales Cid</a:t>
+            </a:r>
+            <a:br/>
+            <a:r>
+              <a:t>• Grupo 6: Fernanda Ovalle, Sebastián Cajales, César Lorca, Jorge Álvarez</a:t>
+            </a:r>
+            <a:br/>
+            <a:r>
+              <a:t>• Docente: Jean Paul Maidana González</a:t>
+            </a:r>
+            <a:br/>
+            <a:r>
+              <a:t>• Magíster en Ciencia de Datos e IA — Universidad Andrés Bello (Octubre 2026)</a:t>
+            </a:r>
+          </a:p>
+        </p:txBody>
+      </p:sp>
+      <p:sp>
+        <p:nvSpPr>
+          <p:cNvPr id="4" name="Rounded Rectangle 3"/>
           <p:cNvSpPr/>
           <p:nvPr/>
         </p:nvSpPr>
         <p:spPr>
           <a:xfrm>
-            <a:off x="914400" y="822960"/>
-            <a:ext cx="2011680" cy="1371600"/>
+            <a:off x="8412480" y="1645920"/>
+            <a:ext cx="3017520" cy="3200400"/>
           </a:xfrm>
           <a:prstGeom prst="roundRect">
             <a:avLst/>
@@ -3937,7 +3972,7 @@
       </p:sp>
       <p:pic>
         <p:nvPicPr>
-          <p:cNvPr id="4" name="Picture 3" descr="logo_unab_color.png"/>
+          <p:cNvPr id="5" name="Picture 4" descr="logo_unab_color.png"/>
           <p:cNvPicPr>
             <a:picLocks noChangeAspect="1"/>
           </p:cNvPicPr>
@@ -3951,170 +3986,14 @@
         </p:blipFill>
         <p:spPr>
           <a:xfrm>
-            <a:off x="1097280" y="914400"/>
-            <a:ext cx="1413762" cy="1188720"/>
+            <a:off x="8641080" y="1874519"/>
+            <a:ext cx="2560320" cy="2152769"/>
           </a:xfrm>
           <a:prstGeom prst="rect">
             <a:avLst/>
           </a:prstGeom>
         </p:spPr>
       </p:pic>
-      <p:sp>
-        <p:nvSpPr>
-          <p:cNvPr id="5" name="TextBox 4"/>
-          <p:cNvSpPr txBox="1"/>
-          <p:nvPr/>
-        </p:nvSpPr>
-        <p:spPr>
-          <a:xfrm>
-            <a:off x="914400" y="2423160"/>
-            <a:ext cx="10332720" cy="365760"/>
-          </a:xfrm>
-          <a:prstGeom prst="rect">
-            <a:avLst/>
-          </a:prstGeom>
-          <a:noFill/>
-        </p:spPr>
-        <p:txBody>
-          <a:bodyPr wrap="none">
-            <a:spAutoFit/>
-          </a:bodyPr>
-          <a:lstStyle/>
-          <a:p>
-            <a:pPr>
-              <a:defRPr sz="1100" b="1">
-                <a:solidFill>
-                  <a:srgbClr val="DC3545"/>
-                </a:solidFill>
-              </a:defRPr>
-            </a:pPr>
-            <a:r>
-              <a:t>MAGÍSTER EN CIENCIA DE DATOS E IA  ·  MCDI501: ESTADÍSTICA COMPUTACIONAL</a:t>
-            </a:r>
-          </a:p>
-        </p:txBody>
-      </p:sp>
-      <p:sp>
-        <p:nvSpPr>
-          <p:cNvPr id="6" name="TextBox 5"/>
-          <p:cNvSpPr txBox="1"/>
-          <p:nvPr/>
-        </p:nvSpPr>
-        <p:spPr>
-          <a:xfrm>
-            <a:off x="914400" y="2834640"/>
-            <a:ext cx="10332720" cy="1463040"/>
-          </a:xfrm>
-          <a:prstGeom prst="rect">
-            <a:avLst/>
-          </a:prstGeom>
-          <a:noFill/>
-        </p:spPr>
-        <p:txBody>
-          <a:bodyPr wrap="square">
-            <a:spAutoFit/>
-          </a:bodyPr>
-          <a:lstStyle/>
-          <a:p>
-            <a:pPr>
-              <a:defRPr sz="3200" b="1">
-                <a:solidFill>
-                  <a:srgbClr val="FFFFFF"/>
-                </a:solidFill>
-              </a:defRPr>
-            </a:pPr>
-            <a:r>
-              <a:t>Modelamiento Predictivo Integrado del</a:t>
-            </a:r>
-            <a:br/>
-            <a:r>
-              <a:t>Atraso Académico en Educación Superior</a:t>
-            </a:r>
-          </a:p>
-        </p:txBody>
-      </p:sp>
-      <p:sp>
-        <p:nvSpPr>
-          <p:cNvPr id="7" name="TextBox 6"/>
-          <p:cNvSpPr txBox="1"/>
-          <p:nvPr/>
-        </p:nvSpPr>
-        <p:spPr>
-          <a:xfrm>
-            <a:off x="914400" y="4434840"/>
-            <a:ext cx="10332720" cy="548640"/>
-          </a:xfrm>
-          <a:prstGeom prst="rect">
-            <a:avLst/>
-          </a:prstGeom>
-          <a:noFill/>
-        </p:spPr>
-        <p:txBody>
-          <a:bodyPr wrap="none">
-            <a:spAutoFit/>
-          </a:bodyPr>
-          <a:lstStyle/>
-          <a:p>
-            <a:pPr>
-              <a:defRPr sz="1600" b="1">
-                <a:solidFill>
-                  <a:srgbClr val="ADB5BD"/>
-                </a:solidFill>
-              </a:defRPr>
-            </a:pPr>
-            <a:r>
-              <a:t>Bloque 4: Estabilidad Bootstrap, Impacto de la Imputación y Recomendaciones</a:t>
-            </a:r>
-          </a:p>
-        </p:txBody>
-      </p:sp>
-      <p:sp>
-        <p:nvSpPr>
-          <p:cNvPr id="8" name="TextBox 7"/>
-          <p:cNvSpPr txBox="1"/>
-          <p:nvPr/>
-        </p:nvSpPr>
-        <p:spPr>
-          <a:xfrm>
-            <a:off x="914400" y="5166360"/>
-            <a:ext cx="10332720" cy="1188720"/>
-          </a:xfrm>
-          <a:prstGeom prst="rect">
-            <a:avLst/>
-          </a:prstGeom>
-          <a:noFill/>
-        </p:spPr>
-        <p:txBody>
-          <a:bodyPr wrap="none">
-            <a:spAutoFit/>
-          </a:bodyPr>
-          <a:lstStyle/>
-          <a:p>
-            <a:pPr>
-              <a:defRPr sz="1300" b="1">
-                <a:solidFill>
-                  <a:srgbClr val="FFFFFF"/>
-                </a:solidFill>
-              </a:defRPr>
-            </a:pPr>
-            <a:r>
-              <a:t>Expositor: Sebastián Cajales Cid (Bloque 4)</a:t>
-            </a:r>
-          </a:p>
-          <a:p>
-            <a:pPr>
-              <a:defRPr sz="1100">
-                <a:solidFill>
-                  <a:srgbClr val="94A3B8"/>
-                </a:solidFill>
-              </a:defRPr>
-            </a:pPr>
-            <a:r>
-              <a:t>Equipo: Fernanda Ovalle Román · Jorge Álvarez Ossandón · César Lorca Bacián · Sebastián Cajales Cid</a:t>
-            </a:r>
-          </a:p>
-        </p:txBody>
-      </p:sp>
     </p:spTree>
   </p:cSld>
   <p:clrMapOvr>
@@ -4135,14 +4014,57 @@
       <p:grpSpPr/>
       <p:sp>
         <p:nvSpPr>
-          <p:cNvPr id="2" name="TextBox 1"/>
+          <p:cNvPr id="2" name="Rectangle 1"/>
+          <p:cNvSpPr/>
+          <p:nvPr/>
+        </p:nvSpPr>
+        <p:spPr>
+          <a:xfrm>
+            <a:off x="0" y="0"/>
+            <a:ext cx="12191695" cy="6858000"/>
+          </a:xfrm>
+          <a:prstGeom prst="rect">
+            <a:avLst/>
+          </a:prstGeom>
+          <a:solidFill>
+            <a:srgbClr val="F8FAFC"/>
+          </a:solidFill>
+          <a:ln>
+            <a:noFill/>
+          </a:ln>
+        </p:spPr>
+        <p:style>
+          <a:lnRef idx="1">
+            <a:schemeClr val="accent1"/>
+          </a:lnRef>
+          <a:fillRef idx="3">
+            <a:schemeClr val="accent1"/>
+          </a:fillRef>
+          <a:effectRef idx="2">
+            <a:schemeClr val="accent1"/>
+          </a:effectRef>
+          <a:fontRef idx="minor">
+            <a:schemeClr val="lt1"/>
+          </a:fontRef>
+        </p:style>
+        <p:txBody>
+          <a:bodyPr rtlCol="0" anchor="ctr"/>
+          <a:lstStyle/>
+          <a:p>
+            <a:pPr algn="ctr"/>
+          </a:p>
+        </p:txBody>
+      </p:sp>
+      <p:sp>
+        <p:nvSpPr>
+          <p:cNvPr id="3" name="TextBox 2"/>
           <p:cNvSpPr txBox="1"/>
           <p:nvPr/>
         </p:nvSpPr>
         <p:spPr>
           <a:xfrm>
             <a:off x="731520" y="365760"/>
-            <a:ext cx="9144000" cy="365760"/>
+            <a:ext cx="10698480" cy="1005840"/>
           </a:xfrm>
           <a:prstGeom prst="rect">
             <a:avLst/>
@@ -4150,7 +4072,7 @@
           <a:noFill/>
         </p:spPr>
         <p:txBody>
-          <a:bodyPr wrap="square">
+          <a:bodyPr wrap="square" lIns="0" tIns="0" rIns="0" bIns="0">
             <a:spAutoFit/>
           </a:bodyPr>
           <a:lstStyle/>
@@ -4158,95 +4080,51 @@
             <a:pPr>
               <a:defRPr sz="1000" b="1">
                 <a:solidFill>
-                  <a:srgbClr val="A6192E"/>
+                  <a:srgbClr val="1E40AF"/>
                 </a:solidFill>
               </a:defRPr>
             </a:pPr>
             <a:r>
-              <a:t>SUMATIVA 3 · BLOQUE 4 · SEBASTIÁN CAJALES</a:t>
-            </a:r>
-          </a:p>
-        </p:txBody>
-      </p:sp>
-      <p:sp>
-        <p:nvSpPr>
-          <p:cNvPr id="3" name="TextBox 2"/>
-          <p:cNvSpPr txBox="1"/>
-          <p:nvPr/>
-        </p:nvSpPr>
-        <p:spPr>
-          <a:xfrm>
-            <a:off x="731520" y="640080"/>
-            <a:ext cx="9326880" cy="731520"/>
-          </a:xfrm>
-          <a:prstGeom prst="rect">
-            <a:avLst/>
-          </a:prstGeom>
-          <a:noFill/>
-        </p:spPr>
-        <p:txBody>
-          <a:bodyPr wrap="square">
-            <a:spAutoFit/>
-          </a:bodyPr>
-          <a:lstStyle/>
+              <a:t>BLOQUE 4 · ROBUSTEZ INFERENCIAL</a:t>
+            </a:r>
+          </a:p>
           <a:p>
             <a:pPr>
+              <a:spcBef>
+                <a:spcPts val="400"/>
+              </a:spcBef>
               <a:defRPr sz="2200" b="1">
                 <a:solidFill>
-                  <a:srgbClr val="1A2C4C"/>
+                  <a:srgbClr val="0F172A"/>
                 </a:solidFill>
               </a:defRPr>
             </a:pPr>
             <a:r>
-              <a:t>Estabilidad Bootstrap (B ≥ 1.000) y Diagnóstico de Supuestos</a:t>
-            </a:r>
-          </a:p>
-        </p:txBody>
-      </p:sp>
-      <p:pic>
-        <p:nvPicPr>
-          <p:cNvPr id="4" name="Picture 3" descr="logo_unab_color.png"/>
-          <p:cNvPicPr>
-            <a:picLocks noChangeAspect="1"/>
-          </p:cNvPicPr>
+              <a:t>Estabilidad Bootstrap (B=1.000) y Dependencia Institucional</a:t>
+            </a:r>
+          </a:p>
+        </p:txBody>
+      </p:sp>
+      <p:sp>
+        <p:nvSpPr>
+          <p:cNvPr id="4" name="Rounded Rectangle 3"/>
+          <p:cNvSpPr/>
           <p:nvPr/>
-        </p:nvPicPr>
-        <p:blipFill>
-          <a:blip r:embed="rId2"/>
-          <a:stretch>
-            <a:fillRect/>
-          </a:stretch>
-        </p:blipFill>
+        </p:nvSpPr>
         <p:spPr>
           <a:xfrm>
-            <a:off x="10332720" y="320040"/>
-            <a:ext cx="1033134" cy="868680"/>
-          </a:xfrm>
-          <a:prstGeom prst="rect">
-            <a:avLst/>
-          </a:prstGeom>
-        </p:spPr>
-      </p:pic>
-      <p:sp>
-        <p:nvSpPr>
-          <p:cNvPr id="5" name="Rounded Rectangle 4"/>
-          <p:cNvSpPr/>
-          <p:nvPr/>
-        </p:nvSpPr>
-        <p:spPr>
-          <a:xfrm>
-            <a:off x="731520" y="1463040"/>
-            <a:ext cx="5120640" cy="4846320"/>
+            <a:off x="731520" y="1554480"/>
+            <a:ext cx="5120640" cy="4754880"/>
           </a:xfrm>
           <a:prstGeom prst="roundRect">
             <a:avLst/>
           </a:prstGeom>
           <a:solidFill>
-            <a:srgbClr val="F8F9FB"/>
+            <a:srgbClr val="FFFFFF"/>
           </a:solidFill>
           <a:ln>
             <a:solidFill>
-              <a:srgbClr val="DEE2E6"/>
+              <a:srgbClr val="E2E8F0"/>
             </a:solidFill>
           </a:ln>
         </p:spPr>
@@ -4265,236 +4143,823 @@
           </a:fontRef>
         </p:style>
         <p:txBody>
-          <a:bodyPr rtlCol="0" anchor="ctr" wrap="square" lIns="365760" rIns="365760" tIns="365760"/>
+          <a:bodyPr rtlCol="0" anchor="ctr" wrap="square" lIns="274320" rIns="274320" tIns="274320"/>
           <a:lstStyle/>
           <a:p>
             <a:pPr algn="ctr">
               <a:defRPr sz="1600" b="1">
                 <a:solidFill>
-                  <a:srgbClr val="1A2C4C"/>
+                  <a:srgbClr val="0F172A"/>
                 </a:solidFill>
               </a:defRPr>
             </a:pPr>
             <a:r>
-              <a:t>Evaluación de Estabilidad por Remuestreo</a:t>
+              <a:t>Inferencia Bootstrap por Conglomerados</a:t>
             </a:r>
           </a:p>
           <a:p>
             <a:pPr>
-              <a:defRPr sz="1100" b="1">
+              <a:spcBef>
+                <a:spcPts val="800"/>
+              </a:spcBef>
+              <a:defRPr b="1" sz="1100">
                 <a:solidFill>
-                  <a:srgbClr val="212529"/>
+                  <a:srgbClr val="1E40AF"/>
                 </a:solidFill>
               </a:defRPr>
             </a:pPr>
             <a:r>
-              <a:t>• Motivación metodológica: </a:t>
-            </a:r>
-            <a:r>
-              <a:rPr b="0" sz="1100">
+              <a:t>• B = 1.000 réplicas no paramétricas: </a:t>
+            </a:r>
+            <a:r>
+              <a:rPr b="0">
                 <a:solidFill>
-                  <a:srgbClr val="6C757D"/>
+                  <a:srgbClr val="0F172A"/>
                 </a:solidFill>
               </a:rPr>
-              <a:t>La inferencia asintótica tradicional (Wald) asume normalidad e independencia estricta. La S2 demostró correlación intra-universidad mediante Jackknife.</a:t>
+              <a:t>Re-entrenamiento completo del modelo logístico M2 por clúster de institución educativa.</a:t>
             </a:r>
           </a:p>
           <a:p>
             <a:pPr>
-              <a:defRPr sz="1100" b="1">
+              <a:spcBef>
+                <a:spcPts val="800"/>
+              </a:spcBef>
+              <a:defRPr b="1" sz="1100">
                 <a:solidFill>
-                  <a:srgbClr val="212529"/>
+                  <a:srgbClr val="1E40AF"/>
                 </a:solidFill>
               </a:defRPr>
             </a:pPr>
             <a:r>
-              <a:t>• Configuración computacional: </a:t>
-            </a:r>
-            <a:r>
-              <a:rPr b="0" sz="1100">
+              <a:t>• Estabilidad de efectos estructurales: </a:t>
+            </a:r>
+            <a:r>
+              <a:rPr b="0">
                 <a:solidFill>
-                  <a:srgbClr val="6C757D"/>
+                  <a:srgbClr val="0F172A"/>
                 </a:solidFill>
               </a:rPr>
-              <a:t>B = 1.000 réplicas no paramétricas sobre el conjunto de Train (70 %, n = 64.167).</a:t>
+              <a:t>Las variables clave mantienen su signo y significancia sin cruzar OR = 1 en ningún remuestreo.</a:t>
             </a:r>
           </a:p>
           <a:p>
             <a:pPr>
-              <a:defRPr sz="1100" b="1">
+              <a:spcBef>
+                <a:spcPts val="800"/>
+              </a:spcBef>
+              <a:defRPr b="1" sz="1100">
                 <a:solidFill>
-                  <a:srgbClr val="212529"/>
+                  <a:srgbClr val="1E40AF"/>
                 </a:solidFill>
               </a:defRPr>
             </a:pPr>
             <a:r>
-              <a:t>• Intervalos al 95 %: </a:t>
-            </a:r>
-            <a:r>
-              <a:rPr b="0" sz="1100">
+              <a:t>• Mujer (vs Hombre): </a:t>
+            </a:r>
+            <a:r>
+              <a:rPr b="0">
                 <a:solidFill>
-                  <a:srgbClr val="6C757D"/>
+                  <a:srgbClr val="0F172A"/>
                 </a:solidFill>
               </a:rPr>
-              <a:t>Cálculo de intervalos Percentil y BCa (Bias-Corrected and Accelerated) para cada coeficiente beta y Odds Ratio.</a:t>
+              <a:t>OR = 0,749 [IC Boot: 0,698; 0,800]. Efecto protector robusto, inmune al método.</a:t>
             </a:r>
           </a:p>
           <a:p>
             <a:pPr>
-              <a:defRPr sz="1100" b="1">
+              <a:spcBef>
+                <a:spcPts val="800"/>
+              </a:spcBef>
+              <a:defRPr b="1" sz="1100">
                 <a:solidFill>
-                  <a:srgbClr val="212529"/>
+                  <a:srgbClr val="1E40AF"/>
                 </a:solidFill>
               </a:defRPr>
             </a:pPr>
             <a:r>
-              <a:t>• Resultado clave: </a:t>
-            </a:r>
-            <a:r>
-              <a:rPr b="0" sz="1100">
+              <a:t>• Áreas de alto rezago: </a:t>
+            </a:r>
+            <a:r>
+              <a:rPr b="0">
                 <a:solidFill>
-                  <a:srgbClr val="6C757D"/>
+                  <a:srgbClr val="0F172A"/>
                 </a:solidFill>
               </a:rPr>
-              <a:t>Alta estabilidad paramétrica. Ningún intervalo de las variables principales cruza el 1.0 (significancia robusta en Jornada Vespertina, Edad y Tecnología).</a:t>
-            </a:r>
-          </a:p>
-        </p:txBody>
-      </p:sp>
-      <p:sp>
-        <p:nvSpPr>
-          <p:cNvPr id="6" name="Rounded Rectangle 5"/>
-          <p:cNvSpPr/>
-          <p:nvPr/>
-        </p:nvSpPr>
-        <p:spPr>
-          <a:xfrm>
-            <a:off x="6217920" y="1463040"/>
-            <a:ext cx="5120640" cy="4846320"/>
-          </a:xfrm>
-          <a:prstGeom prst="roundRect">
-            <a:avLst/>
-          </a:prstGeom>
-          <a:solidFill>
-            <a:srgbClr val="F8F9FB"/>
-          </a:solidFill>
-          <a:ln>
-            <a:solidFill>
-              <a:srgbClr val="DEE2E6"/>
-            </a:solidFill>
-          </a:ln>
-        </p:spPr>
-        <p:style>
-          <a:lnRef idx="1">
-            <a:schemeClr val="accent1"/>
-          </a:lnRef>
-          <a:fillRef idx="3">
-            <a:schemeClr val="accent1"/>
-          </a:fillRef>
-          <a:effectRef idx="2">
-            <a:schemeClr val="accent1"/>
-          </a:effectRef>
-          <a:fontRef idx="minor">
-            <a:schemeClr val="lt1"/>
-          </a:fontRef>
-        </p:style>
-        <p:txBody>
-          <a:bodyPr rtlCol="0" anchor="ctr" wrap="square" lIns="365760" rIns="365760" tIns="365760"/>
-          <a:lstStyle/>
-          <a:p>
-            <a:pPr algn="ctr">
-              <a:defRPr sz="1600" b="1">
+              <a:t>Derecho (OR = 4,42), Agropecuaria (OR = 2,42) y Tecnología/Ingeniería (OR = 2,14).</a:t>
+            </a:r>
+          </a:p>
+          <a:p>
+            <a:pPr>
+              <a:spcBef>
+                <a:spcPts val="800"/>
+              </a:spcBef>
+              <a:defRPr b="1" sz="1100">
                 <a:solidFill>
-                  <a:srgbClr val="1A2C4C"/>
+                  <a:srgbClr val="1E40AF"/>
                 </a:solidFill>
               </a:defRPr>
             </a:pPr>
             <a:r>
-              <a:t>Verificación de Supuestos Logísticos</a:t>
-            </a:r>
-          </a:p>
-          <a:p>
-            <a:pPr>
-              <a:defRPr sz="1100" b="1">
+              <a:t>• Ensanchamiento de intervalos (3,5x - 9,2x): </a:t>
+            </a:r>
+            <a:r>
+              <a:rPr b="0">
                 <a:solidFill>
-                  <a:srgbClr val="212529"/>
-                </a:solidFill>
-              </a:defRPr>
-            </a:pPr>
-            <a:r>
-              <a:t>• Multicolinealidad (VIF): </a:t>
-            </a:r>
-            <a:r>
-              <a:rPr b="0" sz="1100">
-                <a:solidFill>
-                  <a:srgbClr val="6C757D"/>
+                  <a:srgbClr val="0F172A"/>
                 </a:solidFill>
               </a:rPr>
-              <a:t>Factores de Inflación de Varianza controlados (VIF &lt; 5 en todas las variables continuas y dummies).</a:t>
-            </a:r>
-          </a:p>
-          <a:p>
-            <a:pPr>
-              <a:defRPr sz="1100" b="1">
-                <a:solidFill>
-                  <a:srgbClr val="212529"/>
-                </a:solidFill>
-              </a:defRPr>
-            </a:pPr>
-            <a:r>
-              <a:t>• Linealidad en el Logit (Box-Tidwell): </a:t>
-            </a:r>
-            <a:r>
-              <a:rPr b="0" sz="1100">
-                <a:solidFill>
-                  <a:srgbClr val="6C757D"/>
-                </a:solidFill>
-              </a:rPr>
-              <a:t>Contraste de términos X · ln(X) para edad de titulación y duración, validando la relación lineal con el log-odds.</a:t>
-            </a:r>
-          </a:p>
-          <a:p>
-            <a:pPr>
-              <a:defRPr sz="1100" b="1">
-                <a:solidFill>
-                  <a:srgbClr val="212529"/>
-                </a:solidFill>
-              </a:defRPr>
-            </a:pPr>
-            <a:r>
-              <a:t>• Residuos Deviance y Pearson: </a:t>
-            </a:r>
-            <a:r>
-              <a:rPr b="0" sz="1100">
-                <a:solidFill>
-                  <a:srgbClr val="6C757D"/>
-                </a:solidFill>
-              </a:rPr>
-              <a:t>Distribución simétrica de residuos deviance, sin agrupamientos anómalos ni sobredispersión residual severa.</a:t>
-            </a:r>
-          </a:p>
-          <a:p>
-            <a:pPr>
-              <a:defRPr sz="1100" b="1">
-                <a:solidFill>
-                  <a:srgbClr val="212529"/>
-                </a:solidFill>
-              </a:defRPr>
-            </a:pPr>
-            <a:r>
-              <a:t>• Observaciones Influyentes (Cook): </a:t>
-            </a:r>
-            <a:r>
-              <a:rPr b="0" sz="1100">
-                <a:solidFill>
-                  <a:srgbClr val="6C757D"/>
-                </a:solidFill>
-              </a:rPr>
-              <a:t>Análisis de Distancia de Cook y apalancamiento (leverage). Ausencia de casos únicos que determinen los Odds Ratios.</a:t>
-            </a:r>
-          </a:p>
-        </p:txBody>
-      </p:sp>
+              <a:t>Los errores estándar clásicos de Wald subestiman severamente la incertidumbre real al ignorar la correlación intra-universidad (validando Jackknife de S2).</a:t>
+            </a:r>
+          </a:p>
+        </p:txBody>
+      </p:sp>
+      <p:graphicFrame>
+        <p:nvGraphicFramePr>
+          <p:cNvPr id="5" name="Table 4"/>
+          <p:cNvGraphicFramePr>
+            <a:graphicFrameLocks noGrp="1"/>
+          </p:cNvGraphicFramePr>
+          <p:nvPr/>
+        </p:nvGraphicFramePr>
+        <p:xfrm>
+          <a:off x="6126480" y="1554480"/>
+          <a:ext cx="5303520" cy="4754880"/>
+        </p:xfrm>
+        <a:graphic>
+          <a:graphicData uri="http://schemas.openxmlformats.org/drawingml/2006/table">
+            <a:tbl>
+              <a:tblPr firstRow="1" bandRow="1">
+                <a:tableStyleId>{5C22544A-7EE6-4342-B048-85BDC9FD1C3A}</a:tableStyleId>
+              </a:tblPr>
+              <a:tblGrid>
+                <a:gridCol w="2011680"/>
+                <a:gridCol w="914400"/>
+                <a:gridCol w="1463040"/>
+                <a:gridCol w="914400"/>
+              </a:tblGrid>
+              <a:tr h="679268">
+                <a:tc>
+                  <a:txBody>
+                    <a:bodyPr/>
+                    <a:lstStyle/>
+                    <a:p>
+                      <a:pPr algn="l">
+                        <a:defRPr sz="1000" b="1">
+                          <a:solidFill>
+                            <a:srgbClr val="FFFFFF"/>
+                          </a:solidFill>
+                        </a:defRPr>
+                      </a:pPr>
+                      <a:r>
+                        <a:t>Variable / Nivel</a:t>
+                      </a:r>
+                    </a:p>
+                  </a:txBody>
+                  <a:tcPr>
+                    <a:solidFill>
+                      <a:srgbClr val="0F2043"/>
+                    </a:solidFill>
+                  </a:tcPr>
+                </a:tc>
+                <a:tc>
+                  <a:txBody>
+                    <a:bodyPr/>
+                    <a:lstStyle/>
+                    <a:p>
+                      <a:pPr algn="ctr">
+                        <a:defRPr sz="1000" b="1">
+                          <a:solidFill>
+                            <a:srgbClr val="FFFFFF"/>
+                          </a:solidFill>
+                        </a:defRPr>
+                      </a:pPr>
+                      <a:r>
+                        <a:t>OR M2</a:t>
+                      </a:r>
+                    </a:p>
+                  </a:txBody>
+                  <a:tcPr>
+                    <a:solidFill>
+                      <a:srgbClr val="0F2043"/>
+                    </a:solidFill>
+                  </a:tcPr>
+                </a:tc>
+                <a:tc>
+                  <a:txBody>
+                    <a:bodyPr/>
+                    <a:lstStyle/>
+                    <a:p>
+                      <a:pPr algn="ctr">
+                        <a:defRPr sz="1000" b="1">
+                          <a:solidFill>
+                            <a:srgbClr val="FFFFFF"/>
+                          </a:solidFill>
+                        </a:defRPr>
+                      </a:pPr>
+                      <a:r>
+                        <a:t>IC 95% Bootstrap</a:t>
+                      </a:r>
+                    </a:p>
+                  </a:txBody>
+                  <a:tcPr>
+                    <a:solidFill>
+                      <a:srgbClr val="0F2043"/>
+                    </a:solidFill>
+                  </a:tcPr>
+                </a:tc>
+                <a:tc>
+                  <a:txBody>
+                    <a:bodyPr/>
+                    <a:lstStyle/>
+                    <a:p>
+                      <a:pPr algn="ctr">
+                        <a:defRPr sz="1000" b="1">
+                          <a:solidFill>
+                            <a:srgbClr val="FFFFFF"/>
+                          </a:solidFill>
+                        </a:defRPr>
+                      </a:pPr>
+                      <a:r>
+                        <a:t>Ratio Boot/Wald</a:t>
+                      </a:r>
+                    </a:p>
+                  </a:txBody>
+                  <a:tcPr>
+                    <a:solidFill>
+                      <a:srgbClr val="0F2043"/>
+                    </a:solidFill>
+                  </a:tcPr>
+                </a:tc>
+              </a:tr>
+              <a:tr h="679268">
+                <a:tc>
+                  <a:txBody>
+                    <a:bodyPr/>
+                    <a:lstStyle/>
+                    <a:p>
+                      <a:pPr algn="l">
+                        <a:defRPr sz="1000">
+                          <a:solidFill>
+                            <a:srgbClr val="0F172A"/>
+                          </a:solidFill>
+                        </a:defRPr>
+                      </a:pPr>
+                      <a:r>
+                        <a:t>Mujer (vs Hombre)</a:t>
+                      </a:r>
+                    </a:p>
+                  </a:txBody>
+                  <a:tcPr>
+                    <a:solidFill>
+                      <a:srgbClr val="FFFFFF"/>
+                    </a:solidFill>
+                  </a:tcPr>
+                </a:tc>
+                <a:tc>
+                  <a:txBody>
+                    <a:bodyPr/>
+                    <a:lstStyle/>
+                    <a:p>
+                      <a:pPr algn="ctr">
+                        <a:defRPr sz="1000">
+                          <a:solidFill>
+                            <a:srgbClr val="0F172A"/>
+                          </a:solidFill>
+                        </a:defRPr>
+                      </a:pPr>
+                      <a:r>
+                        <a:t>0,75</a:t>
+                      </a:r>
+                    </a:p>
+                  </a:txBody>
+                  <a:tcPr>
+                    <a:solidFill>
+                      <a:srgbClr val="FFFFFF"/>
+                    </a:solidFill>
+                  </a:tcPr>
+                </a:tc>
+                <a:tc>
+                  <a:txBody>
+                    <a:bodyPr/>
+                    <a:lstStyle/>
+                    <a:p>
+                      <a:pPr algn="ctr">
+                        <a:defRPr sz="1000">
+                          <a:solidFill>
+                            <a:srgbClr val="0F172A"/>
+                          </a:solidFill>
+                        </a:defRPr>
+                      </a:pPr>
+                      <a:r>
+                        <a:t>[0,70; 0,80]</a:t>
+                      </a:r>
+                    </a:p>
+                  </a:txBody>
+                  <a:tcPr>
+                    <a:solidFill>
+                      <a:srgbClr val="FFFFFF"/>
+                    </a:solidFill>
+                  </a:tcPr>
+                </a:tc>
+                <a:tc>
+                  <a:txBody>
+                    <a:bodyPr/>
+                    <a:lstStyle/>
+                    <a:p>
+                      <a:pPr algn="ctr">
+                        <a:defRPr sz="1000" b="1">
+                          <a:solidFill>
+                            <a:srgbClr val="B91C1C"/>
+                          </a:solidFill>
+                        </a:defRPr>
+                      </a:pPr>
+                      <a:r>
+                        <a:t>1,78x</a:t>
+                      </a:r>
+                    </a:p>
+                  </a:txBody>
+                  <a:tcPr>
+                    <a:solidFill>
+                      <a:srgbClr val="FFFFFF"/>
+                    </a:solidFill>
+                  </a:tcPr>
+                </a:tc>
+              </a:tr>
+              <a:tr h="679268">
+                <a:tc>
+                  <a:txBody>
+                    <a:bodyPr/>
+                    <a:lstStyle/>
+                    <a:p>
+                      <a:pPr algn="l">
+                        <a:defRPr sz="1000">
+                          <a:solidFill>
+                            <a:srgbClr val="0F172A"/>
+                          </a:solidFill>
+                        </a:defRPr>
+                      </a:pPr>
+                      <a:r>
+                        <a:t>Edad de ingreso (año)</a:t>
+                      </a:r>
+                    </a:p>
+                  </a:txBody>
+                  <a:tcPr>
+                    <a:solidFill>
+                      <a:srgbClr val="F1F5F9"/>
+                    </a:solidFill>
+                  </a:tcPr>
+                </a:tc>
+                <a:tc>
+                  <a:txBody>
+                    <a:bodyPr/>
+                    <a:lstStyle/>
+                    <a:p>
+                      <a:pPr algn="ctr">
+                        <a:defRPr sz="1000">
+                          <a:solidFill>
+                            <a:srgbClr val="0F172A"/>
+                          </a:solidFill>
+                        </a:defRPr>
+                      </a:pPr>
+                      <a:r>
+                        <a:t>1,03</a:t>
+                      </a:r>
+                    </a:p>
+                  </a:txBody>
+                  <a:tcPr>
+                    <a:solidFill>
+                      <a:srgbClr val="F1F5F9"/>
+                    </a:solidFill>
+                  </a:tcPr>
+                </a:tc>
+                <a:tc>
+                  <a:txBody>
+                    <a:bodyPr/>
+                    <a:lstStyle/>
+                    <a:p>
+                      <a:pPr algn="ctr">
+                        <a:defRPr sz="1000">
+                          <a:solidFill>
+                            <a:srgbClr val="0F172A"/>
+                          </a:solidFill>
+                        </a:defRPr>
+                      </a:pPr>
+                      <a:r>
+                        <a:t>[1,02; 1,06]</a:t>
+                      </a:r>
+                    </a:p>
+                  </a:txBody>
+                  <a:tcPr>
+                    <a:solidFill>
+                      <a:srgbClr val="F1F5F9"/>
+                    </a:solidFill>
+                  </a:tcPr>
+                </a:tc>
+                <a:tc>
+                  <a:txBody>
+                    <a:bodyPr/>
+                    <a:lstStyle/>
+                    <a:p>
+                      <a:pPr algn="ctr">
+                        <a:defRPr sz="1000" b="1">
+                          <a:solidFill>
+                            <a:srgbClr val="B91C1C"/>
+                          </a:solidFill>
+                        </a:defRPr>
+                      </a:pPr>
+                      <a:r>
+                        <a:t>5,29x</a:t>
+                      </a:r>
+                    </a:p>
+                  </a:txBody>
+                  <a:tcPr>
+                    <a:solidFill>
+                      <a:srgbClr val="F1F5F9"/>
+                    </a:solidFill>
+                  </a:tcPr>
+                </a:tc>
+              </a:tr>
+              <a:tr h="679268">
+                <a:tc>
+                  <a:txBody>
+                    <a:bodyPr/>
+                    <a:lstStyle/>
+                    <a:p>
+                      <a:pPr algn="l">
+                        <a:defRPr sz="1000">
+                          <a:solidFill>
+                            <a:srgbClr val="0F172A"/>
+                          </a:solidFill>
+                        </a:defRPr>
+                      </a:pPr>
+                      <a:r>
+                        <a:t>Área: Derecho</a:t>
+                      </a:r>
+                    </a:p>
+                  </a:txBody>
+                  <a:tcPr>
+                    <a:solidFill>
+                      <a:srgbClr val="FFFFFF"/>
+                    </a:solidFill>
+                  </a:tcPr>
+                </a:tc>
+                <a:tc>
+                  <a:txBody>
+                    <a:bodyPr/>
+                    <a:lstStyle/>
+                    <a:p>
+                      <a:pPr algn="ctr">
+                        <a:defRPr sz="1000">
+                          <a:solidFill>
+                            <a:srgbClr val="0F172A"/>
+                          </a:solidFill>
+                        </a:defRPr>
+                      </a:pPr>
+                      <a:r>
+                        <a:t>4,42</a:t>
+                      </a:r>
+                    </a:p>
+                  </a:txBody>
+                  <a:tcPr>
+                    <a:solidFill>
+                      <a:srgbClr val="FFFFFF"/>
+                    </a:solidFill>
+                  </a:tcPr>
+                </a:tc>
+                <a:tc>
+                  <a:txBody>
+                    <a:bodyPr/>
+                    <a:lstStyle/>
+                    <a:p>
+                      <a:pPr algn="ctr">
+                        <a:defRPr sz="1000">
+                          <a:solidFill>
+                            <a:srgbClr val="0F172A"/>
+                          </a:solidFill>
+                        </a:defRPr>
+                      </a:pPr>
+                      <a:r>
+                        <a:t>[2,85; 6,52]</a:t>
+                      </a:r>
+                    </a:p>
+                  </a:txBody>
+                  <a:tcPr>
+                    <a:solidFill>
+                      <a:srgbClr val="FFFFFF"/>
+                    </a:solidFill>
+                  </a:tcPr>
+                </a:tc>
+                <a:tc>
+                  <a:txBody>
+                    <a:bodyPr/>
+                    <a:lstStyle/>
+                    <a:p>
+                      <a:pPr algn="ctr">
+                        <a:defRPr sz="1000" b="1">
+                          <a:solidFill>
+                            <a:srgbClr val="B91C1C"/>
+                          </a:solidFill>
+                        </a:defRPr>
+                      </a:pPr>
+                      <a:r>
+                        <a:t>4,93x</a:t>
+                      </a:r>
+                    </a:p>
+                  </a:txBody>
+                  <a:tcPr>
+                    <a:solidFill>
+                      <a:srgbClr val="FFFFFF"/>
+                    </a:solidFill>
+                  </a:tcPr>
+                </a:tc>
+              </a:tr>
+              <a:tr h="679268">
+                <a:tc>
+                  <a:txBody>
+                    <a:bodyPr/>
+                    <a:lstStyle/>
+                    <a:p>
+                      <a:pPr algn="l">
+                        <a:defRPr sz="1000">
+                          <a:solidFill>
+                            <a:srgbClr val="0F172A"/>
+                          </a:solidFill>
+                        </a:defRPr>
+                      </a:pPr>
+                      <a:r>
+                        <a:t>Área: Agropecuaria</a:t>
+                      </a:r>
+                    </a:p>
+                  </a:txBody>
+                  <a:tcPr>
+                    <a:solidFill>
+                      <a:srgbClr val="F1F5F9"/>
+                    </a:solidFill>
+                  </a:tcPr>
+                </a:tc>
+                <a:tc>
+                  <a:txBody>
+                    <a:bodyPr/>
+                    <a:lstStyle/>
+                    <a:p>
+                      <a:pPr algn="ctr">
+                        <a:defRPr sz="1000">
+                          <a:solidFill>
+                            <a:srgbClr val="0F172A"/>
+                          </a:solidFill>
+                        </a:defRPr>
+                      </a:pPr>
+                      <a:r>
+                        <a:t>2,42</a:t>
+                      </a:r>
+                    </a:p>
+                  </a:txBody>
+                  <a:tcPr>
+                    <a:solidFill>
+                      <a:srgbClr val="F1F5F9"/>
+                    </a:solidFill>
+                  </a:tcPr>
+                </a:tc>
+                <a:tc>
+                  <a:txBody>
+                    <a:bodyPr/>
+                    <a:lstStyle/>
+                    <a:p>
+                      <a:pPr algn="ctr">
+                        <a:defRPr sz="1000">
+                          <a:solidFill>
+                            <a:srgbClr val="0F172A"/>
+                          </a:solidFill>
+                        </a:defRPr>
+                      </a:pPr>
+                      <a:r>
+                        <a:t>[1,30; 4,59]</a:t>
+                      </a:r>
+                    </a:p>
+                  </a:txBody>
+                  <a:tcPr>
+                    <a:solidFill>
+                      <a:srgbClr val="F1F5F9"/>
+                    </a:solidFill>
+                  </a:tcPr>
+                </a:tc>
+                <a:tc>
+                  <a:txBody>
+                    <a:bodyPr/>
+                    <a:lstStyle/>
+                    <a:p>
+                      <a:pPr algn="ctr">
+                        <a:defRPr sz="1000" b="1">
+                          <a:solidFill>
+                            <a:srgbClr val="B91C1C"/>
+                          </a:solidFill>
+                        </a:defRPr>
+                      </a:pPr>
+                      <a:r>
+                        <a:t>6,84x</a:t>
+                      </a:r>
+                    </a:p>
+                  </a:txBody>
+                  <a:tcPr>
+                    <a:solidFill>
+                      <a:srgbClr val="F1F5F9"/>
+                    </a:solidFill>
+                  </a:tcPr>
+                </a:tc>
+              </a:tr>
+              <a:tr h="679268">
+                <a:tc>
+                  <a:txBody>
+                    <a:bodyPr/>
+                    <a:lstStyle/>
+                    <a:p>
+                      <a:pPr algn="l">
+                        <a:defRPr sz="1000">
+                          <a:solidFill>
+                            <a:srgbClr val="0F172A"/>
+                          </a:solidFill>
+                        </a:defRPr>
+                      </a:pPr>
+                      <a:r>
+                        <a:t>Área: Tecnología / Ing.</a:t>
+                      </a:r>
+                    </a:p>
+                  </a:txBody>
+                  <a:tcPr>
+                    <a:solidFill>
+                      <a:srgbClr val="FFFFFF"/>
+                    </a:solidFill>
+                  </a:tcPr>
+                </a:tc>
+                <a:tc>
+                  <a:txBody>
+                    <a:bodyPr/>
+                    <a:lstStyle/>
+                    <a:p>
+                      <a:pPr algn="ctr">
+                        <a:defRPr sz="1000">
+                          <a:solidFill>
+                            <a:srgbClr val="0F172A"/>
+                          </a:solidFill>
+                        </a:defRPr>
+                      </a:pPr>
+                      <a:r>
+                        <a:t>2,14</a:t>
+                      </a:r>
+                    </a:p>
+                  </a:txBody>
+                  <a:tcPr>
+                    <a:solidFill>
+                      <a:srgbClr val="FFFFFF"/>
+                    </a:solidFill>
+                  </a:tcPr>
+                </a:tc>
+                <a:tc>
+                  <a:txBody>
+                    <a:bodyPr/>
+                    <a:lstStyle/>
+                    <a:p>
+                      <a:pPr algn="ctr">
+                        <a:defRPr sz="1000">
+                          <a:solidFill>
+                            <a:srgbClr val="0F172A"/>
+                          </a:solidFill>
+                        </a:defRPr>
+                      </a:pPr>
+                      <a:r>
+                        <a:t>[1,45; 3,05]</a:t>
+                      </a:r>
+                    </a:p>
+                  </a:txBody>
+                  <a:tcPr>
+                    <a:solidFill>
+                      <a:srgbClr val="FFFFFF"/>
+                    </a:solidFill>
+                  </a:tcPr>
+                </a:tc>
+                <a:tc>
+                  <a:txBody>
+                    <a:bodyPr/>
+                    <a:lstStyle/>
+                    <a:p>
+                      <a:pPr algn="ctr">
+                        <a:defRPr sz="1000" b="1">
+                          <a:solidFill>
+                            <a:srgbClr val="B91C1C"/>
+                          </a:solidFill>
+                        </a:defRPr>
+                      </a:pPr>
+                      <a:r>
+                        <a:t>6,26x</a:t>
+                      </a:r>
+                    </a:p>
+                  </a:txBody>
+                  <a:tcPr>
+                    <a:solidFill>
+                      <a:srgbClr val="FFFFFF"/>
+                    </a:solidFill>
+                  </a:tcPr>
+                </a:tc>
+              </a:tr>
+              <a:tr h="679272">
+                <a:tc>
+                  <a:txBody>
+                    <a:bodyPr/>
+                    <a:lstStyle/>
+                    <a:p>
+                      <a:pPr algn="l">
+                        <a:defRPr sz="1000">
+                          <a:solidFill>
+                            <a:srgbClr val="0F172A"/>
+                          </a:solidFill>
+                        </a:defRPr>
+                      </a:pPr>
+                      <a:r>
+                        <a:t>Jornada: Diurna</a:t>
+                      </a:r>
+                    </a:p>
+                  </a:txBody>
+                  <a:tcPr>
+                    <a:solidFill>
+                      <a:srgbClr val="F1F5F9"/>
+                    </a:solidFill>
+                  </a:tcPr>
+                </a:tc>
+                <a:tc>
+                  <a:txBody>
+                    <a:bodyPr/>
+                    <a:lstStyle/>
+                    <a:p>
+                      <a:pPr algn="ctr">
+                        <a:defRPr sz="1000">
+                          <a:solidFill>
+                            <a:srgbClr val="0F172A"/>
+                          </a:solidFill>
+                        </a:defRPr>
+                      </a:pPr>
+                      <a:r>
+                        <a:t>2,26</a:t>
+                      </a:r>
+                    </a:p>
+                  </a:txBody>
+                  <a:tcPr>
+                    <a:solidFill>
+                      <a:srgbClr val="F1F5F9"/>
+                    </a:solidFill>
+                  </a:tcPr>
+                </a:tc>
+                <a:tc>
+                  <a:txBody>
+                    <a:bodyPr/>
+                    <a:lstStyle/>
+                    <a:p>
+                      <a:pPr algn="ctr">
+                        <a:defRPr sz="1000">
+                          <a:solidFill>
+                            <a:srgbClr val="0F172A"/>
+                          </a:solidFill>
+                        </a:defRPr>
+                      </a:pPr>
+                      <a:r>
+                        <a:t>[1,04; 4,78]</a:t>
+                      </a:r>
+                    </a:p>
+                  </a:txBody>
+                  <a:tcPr>
+                    <a:solidFill>
+                      <a:srgbClr val="F1F5F9"/>
+                    </a:solidFill>
+                  </a:tcPr>
+                </a:tc>
+                <a:tc>
+                  <a:txBody>
+                    <a:bodyPr/>
+                    <a:lstStyle/>
+                    <a:p>
+                      <a:pPr algn="ctr">
+                        <a:defRPr sz="1000" b="1">
+                          <a:solidFill>
+                            <a:srgbClr val="B91C1C"/>
+                          </a:solidFill>
+                        </a:defRPr>
+                      </a:pPr>
+                      <a:r>
+                        <a:t>9,16x</a:t>
+                      </a:r>
+                    </a:p>
+                  </a:txBody>
+                  <a:tcPr>
+                    <a:solidFill>
+                      <a:srgbClr val="F1F5F9"/>
+                    </a:solidFill>
+                  </a:tcPr>
+                </a:tc>
+              </a:tr>
+            </a:tbl>
+          </a:graphicData>
+        </a:graphic>
+      </p:graphicFrame>
     </p:spTree>
   </p:cSld>
   <p:clrMapOvr>
@@ -4515,14 +4980,57 @@
       <p:grpSpPr/>
       <p:sp>
         <p:nvSpPr>
-          <p:cNvPr id="2" name="TextBox 1"/>
+          <p:cNvPr id="2" name="Rectangle 1"/>
+          <p:cNvSpPr/>
+          <p:nvPr/>
+        </p:nvSpPr>
+        <p:spPr>
+          <a:xfrm>
+            <a:off x="0" y="0"/>
+            <a:ext cx="12191695" cy="6858000"/>
+          </a:xfrm>
+          <a:prstGeom prst="rect">
+            <a:avLst/>
+          </a:prstGeom>
+          <a:solidFill>
+            <a:srgbClr val="F8FAFC"/>
+          </a:solidFill>
+          <a:ln>
+            <a:noFill/>
+          </a:ln>
+        </p:spPr>
+        <p:style>
+          <a:lnRef idx="1">
+            <a:schemeClr val="accent1"/>
+          </a:lnRef>
+          <a:fillRef idx="3">
+            <a:schemeClr val="accent1"/>
+          </a:fillRef>
+          <a:effectRef idx="2">
+            <a:schemeClr val="accent1"/>
+          </a:effectRef>
+          <a:fontRef idx="minor">
+            <a:schemeClr val="lt1"/>
+          </a:fontRef>
+        </p:style>
+        <p:txBody>
+          <a:bodyPr rtlCol="0" anchor="ctr"/>
+          <a:lstStyle/>
+          <a:p>
+            <a:pPr algn="ctr"/>
+          </a:p>
+        </p:txBody>
+      </p:sp>
+      <p:sp>
+        <p:nvSpPr>
+          <p:cNvPr id="3" name="TextBox 2"/>
           <p:cNvSpPr txBox="1"/>
           <p:nvPr/>
         </p:nvSpPr>
         <p:spPr>
           <a:xfrm>
             <a:off x="731520" y="365760"/>
-            <a:ext cx="9144000" cy="365760"/>
+            <a:ext cx="10698480" cy="1005840"/>
           </a:xfrm>
           <a:prstGeom prst="rect">
             <a:avLst/>
@@ -4530,7 +5038,7 @@
           <a:noFill/>
         </p:spPr>
         <p:txBody>
-          <a:bodyPr wrap="square">
+          <a:bodyPr wrap="square" lIns="0" tIns="0" rIns="0" bIns="0">
             <a:spAutoFit/>
           </a:bodyPr>
           <a:lstStyle/>
@@ -4538,75 +5046,645 @@
             <a:pPr>
               <a:defRPr sz="1000" b="1">
                 <a:solidFill>
-                  <a:srgbClr val="A6192E"/>
+                  <a:srgbClr val="1E40AF"/>
                 </a:solidFill>
               </a:defRPr>
             </a:pPr>
             <a:r>
-              <a:t>SUMATIVA 3 · BLOQUE 4 · SEBASTIÁN CAJALES</a:t>
-            </a:r>
-          </a:p>
-        </p:txBody>
-      </p:sp>
-      <p:sp>
-        <p:nvSpPr>
-          <p:cNvPr id="3" name="TextBox 2"/>
-          <p:cNvSpPr txBox="1"/>
-          <p:nvPr/>
-        </p:nvSpPr>
-        <p:spPr>
-          <a:xfrm>
-            <a:off x="731520" y="640080"/>
-            <a:ext cx="9326880" cy="731520"/>
-          </a:xfrm>
-          <a:prstGeom prst="rect">
-            <a:avLst/>
-          </a:prstGeom>
-          <a:noFill/>
-        </p:spPr>
-        <p:txBody>
-          <a:bodyPr wrap="square">
-            <a:spAutoFit/>
-          </a:bodyPr>
-          <a:lstStyle/>
+              <a:t>BLOQUE 4 · COMPARACIÓN METODOLÓGICA (E1 / E2 / E3 / MI)</a:t>
+            </a:r>
+          </a:p>
           <a:p>
             <a:pPr>
+              <a:spcBef>
+                <a:spcPts val="400"/>
+              </a:spcBef>
               <a:defRPr sz="2200" b="1">
                 <a:solidFill>
-                  <a:srgbClr val="1A2C4C"/>
+                  <a:srgbClr val="0F172A"/>
                 </a:solidFill>
               </a:defRPr>
             </a:pPr>
             <a:r>
-              <a:t>Impacto Analítico de la Estrategia de Imputación</a:t>
-            </a:r>
-          </a:p>
-        </p:txBody>
-      </p:sp>
-      <p:pic>
-        <p:nvPicPr>
-          <p:cNvPr id="4" name="Picture 3" descr="logo_unab_color.png"/>
-          <p:cNvPicPr>
-            <a:picLocks noChangeAspect="1"/>
-          </p:cNvPicPr>
+              <a:t>Impacto de la Imputación y el Hallazgo de No-Congenialidad</a:t>
+            </a:r>
+          </a:p>
+        </p:txBody>
+      </p:sp>
+      <p:graphicFrame>
+        <p:nvGraphicFramePr>
+          <p:cNvPr id="4" name="Table 3"/>
+          <p:cNvGraphicFramePr>
+            <a:graphicFrameLocks noGrp="1"/>
+          </p:cNvGraphicFramePr>
           <p:nvPr/>
-        </p:nvPicPr>
-        <p:blipFill>
-          <a:blip r:embed="rId2"/>
-          <a:stretch>
-            <a:fillRect/>
-          </a:stretch>
-        </p:blipFill>
-        <p:spPr>
-          <a:xfrm>
-            <a:off x="10332720" y="320040"/>
-            <a:ext cx="1033134" cy="868680"/>
-          </a:xfrm>
-          <a:prstGeom prst="rect">
-            <a:avLst/>
-          </a:prstGeom>
-        </p:spPr>
-      </p:pic>
+        </p:nvGraphicFramePr>
+        <p:xfrm>
+          <a:off x="731520" y="1463040"/>
+          <a:ext cx="10698480" cy="2011680"/>
+        </p:xfrm>
+        <a:graphic>
+          <a:graphicData uri="http://schemas.openxmlformats.org/drawingml/2006/table">
+            <a:tbl>
+              <a:tblPr firstRow="1" bandRow="1">
+                <a:tableStyleId>{5C22544A-7EE6-4342-B048-85BDC9FD1C3A}</a:tableStyleId>
+              </a:tblPr>
+              <a:tblGrid>
+                <a:gridCol w="2926080"/>
+                <a:gridCol w="1828800"/>
+                <a:gridCol w="2103120"/>
+                <a:gridCol w="2011680"/>
+                <a:gridCol w="1828800"/>
+              </a:tblGrid>
+              <a:tr h="402336">
+                <a:tc>
+                  <a:txBody>
+                    <a:bodyPr/>
+                    <a:lstStyle/>
+                    <a:p>
+                      <a:pPr algn="l">
+                        <a:defRPr sz="1000" b="1">
+                          <a:solidFill>
+                            <a:srgbClr val="FFFFFF"/>
+                          </a:solidFill>
+                        </a:defRPr>
+                      </a:pPr>
+                      <a:r>
+                        <a:t>Estrategia de Imputación</a:t>
+                      </a:r>
+                    </a:p>
+                  </a:txBody>
+                  <a:tcPr>
+                    <a:solidFill>
+                      <a:srgbClr val="0F2043"/>
+                    </a:solidFill>
+                  </a:tcPr>
+                </a:tc>
+                <a:tc>
+                  <a:txBody>
+                    <a:bodyPr/>
+                    <a:lstStyle/>
+                    <a:p>
+                      <a:pPr algn="ctr">
+                        <a:defRPr sz="1000" b="1">
+                          <a:solidFill>
+                            <a:srgbClr val="FFFFFF"/>
+                          </a:solidFill>
+                        </a:defRPr>
+                      </a:pPr>
+                      <a:r>
+                        <a:t>AUC en Prueba Común</a:t>
+                      </a:r>
+                    </a:p>
+                  </a:txBody>
+                  <a:tcPr>
+                    <a:solidFill>
+                      <a:srgbClr val="0F2043"/>
+                    </a:solidFill>
+                  </a:tcPr>
+                </a:tc>
+                <a:tc>
+                  <a:txBody>
+                    <a:bodyPr/>
+                    <a:lstStyle/>
+                    <a:p>
+                      <a:pPr algn="ctr">
+                        <a:defRPr sz="1000" b="1">
+                          <a:solidFill>
+                            <a:srgbClr val="FFFFFF"/>
+                          </a:solidFill>
+                        </a:defRPr>
+                      </a:pPr>
+                      <a:r>
+                        <a:t>Δ AUC vs E1 [IC 95%]</a:t>
+                      </a:r>
+                    </a:p>
+                  </a:txBody>
+                  <a:tcPr>
+                    <a:solidFill>
+                      <a:srgbClr val="0F2043"/>
+                    </a:solidFill>
+                  </a:tcPr>
+                </a:tc>
+                <a:tc>
+                  <a:txBody>
+                    <a:bodyPr/>
+                    <a:lstStyle/>
+                    <a:p>
+                      <a:pPr algn="ctr">
+                        <a:defRPr sz="1000" b="1">
+                          <a:solidFill>
+                            <a:srgbClr val="FFFFFF"/>
+                          </a:solidFill>
+                        </a:defRPr>
+                      </a:pPr>
+                      <a:r>
+                        <a:t>Exactitud</a:t>
+                      </a:r>
+                    </a:p>
+                  </a:txBody>
+                  <a:tcPr>
+                    <a:solidFill>
+                      <a:srgbClr val="0F2043"/>
+                    </a:solidFill>
+                  </a:tcPr>
+                </a:tc>
+                <a:tc>
+                  <a:txBody>
+                    <a:bodyPr/>
+                    <a:lstStyle/>
+                    <a:p>
+                      <a:pPr algn="ctr">
+                        <a:defRPr sz="1000" b="1">
+                          <a:solidFill>
+                            <a:srgbClr val="FFFFFF"/>
+                          </a:solidFill>
+                        </a:defRPr>
+                      </a:pPr>
+                      <a:r>
+                        <a:t>Prob. Media Predicha</a:t>
+                      </a:r>
+                    </a:p>
+                  </a:txBody>
+                  <a:tcPr>
+                    <a:solidFill>
+                      <a:srgbClr val="0F2043"/>
+                    </a:solidFill>
+                  </a:tcPr>
+                </a:tc>
+              </a:tr>
+              <a:tr h="402336">
+                <a:tc>
+                  <a:txBody>
+                    <a:bodyPr/>
+                    <a:lstStyle/>
+                    <a:p>
+                      <a:pPr algn="l">
+                        <a:defRPr sz="1000">
+                          <a:solidFill>
+                            <a:srgbClr val="0F172A"/>
+                          </a:solidFill>
+                        </a:defRPr>
+                      </a:pPr>
+                      <a:r>
+                        <a:t>E1 · Eliminación (Casos completos)</a:t>
+                      </a:r>
+                    </a:p>
+                  </a:txBody>
+                  <a:tcPr>
+                    <a:solidFill>
+                      <a:srgbClr val="FFFFFF"/>
+                    </a:solidFill>
+                  </a:tcPr>
+                </a:tc>
+                <a:tc>
+                  <a:txBody>
+                    <a:bodyPr/>
+                    <a:lstStyle/>
+                    <a:p>
+                      <a:pPr algn="ctr">
+                        <a:defRPr sz="1000">
+                          <a:solidFill>
+                            <a:srgbClr val="0F172A"/>
+                          </a:solidFill>
+                        </a:defRPr>
+                      </a:pPr>
+                      <a:r>
+                        <a:t>0,6666</a:t>
+                      </a:r>
+                    </a:p>
+                  </a:txBody>
+                  <a:tcPr>
+                    <a:solidFill>
+                      <a:srgbClr val="FFFFFF"/>
+                    </a:solidFill>
+                  </a:tcPr>
+                </a:tc>
+                <a:tc>
+                  <a:txBody>
+                    <a:bodyPr/>
+                    <a:lstStyle/>
+                    <a:p>
+                      <a:pPr algn="ctr">
+                        <a:defRPr sz="1000">
+                          <a:solidFill>
+                            <a:srgbClr val="0F172A"/>
+                          </a:solidFill>
+                        </a:defRPr>
+                      </a:pPr>
+                      <a:r>
+                        <a:t>Referencia</a:t>
+                      </a:r>
+                    </a:p>
+                  </a:txBody>
+                  <a:tcPr>
+                    <a:solidFill>
+                      <a:srgbClr val="FFFFFF"/>
+                    </a:solidFill>
+                  </a:tcPr>
+                </a:tc>
+                <a:tc>
+                  <a:txBody>
+                    <a:bodyPr/>
+                    <a:lstStyle/>
+                    <a:p>
+                      <a:pPr algn="ctr">
+                        <a:defRPr sz="1000">
+                          <a:solidFill>
+                            <a:srgbClr val="0F172A"/>
+                          </a:solidFill>
+                        </a:defRPr>
+                      </a:pPr>
+                      <a:r>
+                        <a:t>65,55 %</a:t>
+                      </a:r>
+                    </a:p>
+                  </a:txBody>
+                  <a:tcPr>
+                    <a:solidFill>
+                      <a:srgbClr val="FFFFFF"/>
+                    </a:solidFill>
+                  </a:tcPr>
+                </a:tc>
+                <a:tc>
+                  <a:txBody>
+                    <a:bodyPr/>
+                    <a:lstStyle/>
+                    <a:p>
+                      <a:pPr algn="ctr">
+                        <a:defRPr sz="1000">
+                          <a:solidFill>
+                            <a:srgbClr val="0F172A"/>
+                          </a:solidFill>
+                        </a:defRPr>
+                      </a:pPr>
+                      <a:r>
+                        <a:t>24,57 % (Real: 24,53%)</a:t>
+                      </a:r>
+                    </a:p>
+                  </a:txBody>
+                  <a:tcPr>
+                    <a:solidFill>
+                      <a:srgbClr val="FFFFFF"/>
+                    </a:solidFill>
+                  </a:tcPr>
+                </a:tc>
+              </a:tr>
+              <a:tr h="402336">
+                <a:tc>
+                  <a:txBody>
+                    <a:bodyPr/>
+                    <a:lstStyle/>
+                    <a:p>
+                      <a:pPr algn="l">
+                        <a:defRPr sz="1000">
+                          <a:solidFill>
+                            <a:srgbClr val="0F172A"/>
+                          </a:solidFill>
+                        </a:defRPr>
+                      </a:pPr>
+                      <a:r>
+                        <a:t>E2 · Imputación simple (Mediana)</a:t>
+                      </a:r>
+                    </a:p>
+                  </a:txBody>
+                  <a:tcPr>
+                    <a:solidFill>
+                      <a:srgbClr val="FEF2F2"/>
+                    </a:solidFill>
+                  </a:tcPr>
+                </a:tc>
+                <a:tc>
+                  <a:txBody>
+                    <a:bodyPr/>
+                    <a:lstStyle/>
+                    <a:p>
+                      <a:pPr algn="ctr">
+                        <a:defRPr sz="1000">
+                          <a:solidFill>
+                            <a:srgbClr val="0F172A"/>
+                          </a:solidFill>
+                        </a:defRPr>
+                      </a:pPr>
+                      <a:r>
+                        <a:t>0,6442</a:t>
+                      </a:r>
+                    </a:p>
+                  </a:txBody>
+                  <a:tcPr>
+                    <a:solidFill>
+                      <a:srgbClr val="FEF2F2"/>
+                    </a:solidFill>
+                  </a:tcPr>
+                </a:tc>
+                <a:tc>
+                  <a:txBody>
+                    <a:bodyPr/>
+                    <a:lstStyle/>
+                    <a:p>
+                      <a:pPr algn="ctr">
+                        <a:defRPr sz="1000">
+                          <a:solidFill>
+                            <a:srgbClr val="0F172A"/>
+                          </a:solidFill>
+                        </a:defRPr>
+                      </a:pPr>
+                      <a:r>
+                        <a:t>-0,0224 [-0,027; -0,019]</a:t>
+                      </a:r>
+                    </a:p>
+                  </a:txBody>
+                  <a:tcPr>
+                    <a:solidFill>
+                      <a:srgbClr val="FEF2F2"/>
+                    </a:solidFill>
+                  </a:tcPr>
+                </a:tc>
+                <a:tc>
+                  <a:txBody>
+                    <a:bodyPr/>
+                    <a:lstStyle/>
+                    <a:p>
+                      <a:pPr algn="ctr">
+                        <a:defRPr sz="1000">
+                          <a:solidFill>
+                            <a:srgbClr val="0F172A"/>
+                          </a:solidFill>
+                        </a:defRPr>
+                      </a:pPr>
+                      <a:r>
+                        <a:t>65,40 %</a:t>
+                      </a:r>
+                    </a:p>
+                  </a:txBody>
+                  <a:tcPr>
+                    <a:solidFill>
+                      <a:srgbClr val="FEF2F2"/>
+                    </a:solidFill>
+                  </a:tcPr>
+                </a:tc>
+                <a:tc>
+                  <a:txBody>
+                    <a:bodyPr/>
+                    <a:lstStyle/>
+                    <a:p>
+                      <a:pPr algn="ctr">
+                        <a:defRPr sz="1000">
+                          <a:solidFill>
+                            <a:srgbClr val="0F172A"/>
+                          </a:solidFill>
+                        </a:defRPr>
+                      </a:pPr>
+                      <a:r>
+                        <a:t>28,03 % (Sobrestima 3,5%)</a:t>
+                      </a:r>
+                    </a:p>
+                  </a:txBody>
+                  <a:tcPr>
+                    <a:solidFill>
+                      <a:srgbClr val="FEF2F2"/>
+                    </a:solidFill>
+                  </a:tcPr>
+                </a:tc>
+              </a:tr>
+              <a:tr h="402336">
+                <a:tc>
+                  <a:txBody>
+                    <a:bodyPr/>
+                    <a:lstStyle/>
+                    <a:p>
+                      <a:pPr algn="l">
+                        <a:defRPr sz="1000">
+                          <a:solidFill>
+                            <a:srgbClr val="0F172A"/>
+                          </a:solidFill>
+                        </a:defRPr>
+                      </a:pPr>
+                      <a:r>
+                        <a:t>E3 · Regresión lineal multivariada</a:t>
+                      </a:r>
+                    </a:p>
+                  </a:txBody>
+                  <a:tcPr>
+                    <a:solidFill>
+                      <a:srgbClr val="FFFFFF"/>
+                    </a:solidFill>
+                  </a:tcPr>
+                </a:tc>
+                <a:tc>
+                  <a:txBody>
+                    <a:bodyPr/>
+                    <a:lstStyle/>
+                    <a:p>
+                      <a:pPr algn="ctr">
+                        <a:defRPr sz="1000">
+                          <a:solidFill>
+                            <a:srgbClr val="0F172A"/>
+                          </a:solidFill>
+                        </a:defRPr>
+                      </a:pPr>
+                      <a:r>
+                        <a:t>0,6617</a:t>
+                      </a:r>
+                    </a:p>
+                  </a:txBody>
+                  <a:tcPr>
+                    <a:solidFill>
+                      <a:srgbClr val="FFFFFF"/>
+                    </a:solidFill>
+                  </a:tcPr>
+                </a:tc>
+                <a:tc>
+                  <a:txBody>
+                    <a:bodyPr/>
+                    <a:lstStyle/>
+                    <a:p>
+                      <a:pPr algn="ctr">
+                        <a:defRPr sz="1000">
+                          <a:solidFill>
+                            <a:srgbClr val="0F172A"/>
+                          </a:solidFill>
+                        </a:defRPr>
+                      </a:pPr>
+                      <a:r>
+                        <a:t>-0,0049 [-0,007; -0,003]</a:t>
+                      </a:r>
+                    </a:p>
+                  </a:txBody>
+                  <a:tcPr>
+                    <a:solidFill>
+                      <a:srgbClr val="FFFFFF"/>
+                    </a:solidFill>
+                  </a:tcPr>
+                </a:tc>
+                <a:tc>
+                  <a:txBody>
+                    <a:bodyPr/>
+                    <a:lstStyle/>
+                    <a:p>
+                      <a:pPr algn="ctr">
+                        <a:defRPr sz="1000">
+                          <a:solidFill>
+                            <a:srgbClr val="0F172A"/>
+                          </a:solidFill>
+                        </a:defRPr>
+                      </a:pPr>
+                      <a:r>
+                        <a:t>65,30 %</a:t>
+                      </a:r>
+                    </a:p>
+                  </a:txBody>
+                  <a:tcPr>
+                    <a:solidFill>
+                      <a:srgbClr val="FFFFFF"/>
+                    </a:solidFill>
+                  </a:tcPr>
+                </a:tc>
+                <a:tc>
+                  <a:txBody>
+                    <a:bodyPr/>
+                    <a:lstStyle/>
+                    <a:p>
+                      <a:pPr algn="ctr">
+                        <a:defRPr sz="1000">
+                          <a:solidFill>
+                            <a:srgbClr val="0F172A"/>
+                          </a:solidFill>
+                        </a:defRPr>
+                      </a:pPr>
+                      <a:r>
+                        <a:t>24,16 % (Bien calibrada)</a:t>
+                      </a:r>
+                    </a:p>
+                  </a:txBody>
+                  <a:tcPr>
+                    <a:solidFill>
+                      <a:srgbClr val="FFFFFF"/>
+                    </a:solidFill>
+                  </a:tcPr>
+                </a:tc>
+              </a:tr>
+              <a:tr h="402336">
+                <a:tc>
+                  <a:txBody>
+                    <a:bodyPr/>
+                    <a:lstStyle/>
+                    <a:p>
+                      <a:pPr algn="l">
+                        <a:defRPr sz="1000" b="1">
+                          <a:solidFill>
+                            <a:srgbClr val="0F172A"/>
+                          </a:solidFill>
+                        </a:defRPr>
+                      </a:pPr>
+                      <a:r>
+                        <a:t>MI · Imputación Múltiple Congeniada (m=20)</a:t>
+                      </a:r>
+                    </a:p>
+                  </a:txBody>
+                  <a:tcPr>
+                    <a:solidFill>
+                      <a:srgbClr val="ECFDF5"/>
+                    </a:solidFill>
+                  </a:tcPr>
+                </a:tc>
+                <a:tc>
+                  <a:txBody>
+                    <a:bodyPr/>
+                    <a:lstStyle/>
+                    <a:p>
+                      <a:pPr algn="ctr">
+                        <a:defRPr sz="1000" b="1">
+                          <a:solidFill>
+                            <a:srgbClr val="0F172A"/>
+                          </a:solidFill>
+                        </a:defRPr>
+                      </a:pPr>
+                      <a:r>
+                        <a:t>0,6640</a:t>
+                      </a:r>
+                    </a:p>
+                  </a:txBody>
+                  <a:tcPr>
+                    <a:solidFill>
+                      <a:srgbClr val="ECFDF5"/>
+                    </a:solidFill>
+                  </a:tcPr>
+                </a:tc>
+                <a:tc>
+                  <a:txBody>
+                    <a:bodyPr/>
+                    <a:lstStyle/>
+                    <a:p>
+                      <a:pPr algn="ctr">
+                        <a:defRPr sz="1000" b="1">
+                          <a:solidFill>
+                            <a:srgbClr val="0F172A"/>
+                          </a:solidFill>
+                        </a:defRPr>
+                      </a:pPr>
+                      <a:r>
+                        <a:t>-0,0026 [-0,004; -0,001]</a:t>
+                      </a:r>
+                    </a:p>
+                  </a:txBody>
+                  <a:tcPr>
+                    <a:solidFill>
+                      <a:srgbClr val="ECFDF5"/>
+                    </a:solidFill>
+                  </a:tcPr>
+                </a:tc>
+                <a:tc>
+                  <a:txBody>
+                    <a:bodyPr/>
+                    <a:lstStyle/>
+                    <a:p>
+                      <a:pPr algn="ctr">
+                        <a:defRPr sz="1000" b="1">
+                          <a:solidFill>
+                            <a:srgbClr val="0F172A"/>
+                          </a:solidFill>
+                        </a:defRPr>
+                      </a:pPr>
+                      <a:r>
+                        <a:t>65,50 %</a:t>
+                      </a:r>
+                    </a:p>
+                  </a:txBody>
+                  <a:tcPr>
+                    <a:solidFill>
+                      <a:srgbClr val="ECFDF5"/>
+                    </a:solidFill>
+                  </a:tcPr>
+                </a:tc>
+                <a:tc>
+                  <a:txBody>
+                    <a:bodyPr/>
+                    <a:lstStyle/>
+                    <a:p>
+                      <a:pPr algn="ctr">
+                        <a:defRPr sz="1000" b="1">
+                          <a:solidFill>
+                            <a:srgbClr val="0F172A"/>
+                          </a:solidFill>
+                        </a:defRPr>
+                      </a:pPr>
+                      <a:r>
+                        <a:t>24,40 % (Óptima)</a:t>
+                      </a:r>
+                    </a:p>
+                  </a:txBody>
+                  <a:tcPr>
+                    <a:solidFill>
+                      <a:srgbClr val="ECFDF5"/>
+                    </a:solidFill>
+                  </a:tcPr>
+                </a:tc>
+              </a:tr>
+            </a:tbl>
+          </a:graphicData>
+        </a:graphic>
+      </p:graphicFrame>
       <p:sp>
         <p:nvSpPr>
           <p:cNvPr id="5" name="Rounded Rectangle 4"/>
@@ -4615,18 +5693,18 @@
         </p:nvSpPr>
         <p:spPr>
           <a:xfrm>
-            <a:off x="731520" y="1463040"/>
-            <a:ext cx="3337560" cy="4846320"/>
+            <a:off x="731520" y="3749039"/>
+            <a:ext cx="5212080" cy="2560320"/>
           </a:xfrm>
           <a:prstGeom prst="roundRect">
             <a:avLst/>
           </a:prstGeom>
           <a:solidFill>
-            <a:srgbClr val="F8F9FB"/>
+            <a:srgbClr val="FFFFFF"/>
           </a:solidFill>
-          <a:ln w="12700">
+          <a:ln>
             <a:solidFill>
-              <a:srgbClr val="6C757D"/>
+              <a:srgbClr val="E2E8F0"/>
             </a:solidFill>
           </a:ln>
         </p:spPr>
@@ -4645,111 +5723,63 @@
           </a:fontRef>
         </p:style>
         <p:txBody>
-          <a:bodyPr rtlCol="0" anchor="ctr" wrap="square" lIns="228600" rIns="228600" tIns="274320"/>
+          <a:bodyPr rtlCol="0" anchor="ctr" wrap="square" lIns="228600" tIns="228600" rIns="228600"/>
           <a:lstStyle/>
           <a:p>
             <a:pPr algn="ctr">
-              <a:defRPr sz="1400" b="1">
+              <a:defRPr sz="1300" b="1">
                 <a:solidFill>
-                  <a:srgbClr val="1A2C4C"/>
+                  <a:srgbClr val="B91C1C"/>
                 </a:solidFill>
               </a:defRPr>
             </a:pPr>
             <a:r>
-              <a:t>1. Eliminación Listwise</a:t>
+              <a:t>El Diagnóstico de No-Congenialidad en E3</a:t>
             </a:r>
           </a:p>
           <a:p>
             <a:pPr>
-              <a:defRPr sz="950" b="1">
+              <a:spcBef>
+                <a:spcPts val="400"/>
+              </a:spcBef>
+              <a:defRPr sz="1000">
                 <a:solidFill>
-                  <a:srgbClr val="6C757D"/>
+                  <a:srgbClr val="0F172A"/>
                 </a:solidFill>
               </a:defRPr>
             </a:pPr>
             <a:r>
-              <a:t>Complete-case analysis · n = 91.667 (-12,75 %)</a:t>
-            </a:r>
-          </a:p>
-          <a:p/>
+              <a:t>• Omisión de Jornada en la Imputación: E3 predijo la duración sin incluir jornada, asignando un atraso plano de ~20% a todos los imputados.</a:t>
+            </a:r>
+          </a:p>
           <a:p>
             <a:pPr>
-              <a:defRPr sz="1000" b="1">
+              <a:spcBef>
+                <a:spcPts val="400"/>
+              </a:spcBef>
+              <a:defRPr sz="1000">
                 <a:solidFill>
-                  <a:srgbClr val="212529"/>
+                  <a:srgbClr val="0F172A"/>
                 </a:solidFill>
               </a:defRPr>
             </a:pPr>
             <a:r>
-              <a:t>• Pérdida muestral: </a:t>
-            </a:r>
-            <a:r>
-              <a:rPr b="0" sz="950">
+              <a:t>• Distorsión de Odds Ratios: Como 'A Distancia' concentraba 75,9% de faltantes, su atraso bajó artificialmente, haciendo que Diurna subiera a OR = 2,26 y Semipresencial cruzara el 1 (de 0,51 a 1,08).</a:t>
+            </a:r>
+          </a:p>
+          <a:p>
+            <a:pPr>
+              <a:spcBef>
+                <a:spcPts val="400"/>
+              </a:spcBef>
+              <a:defRPr sz="1000">
                 <a:solidFill>
-                  <a:srgbClr val="6C757D"/>
-                </a:solidFill>
-              </a:rPr>
-              <a:t>Descarta 13.396 estudiantes reales.</a:t>
-            </a:r>
-          </a:p>
-          <a:p>
-            <a:pPr>
-              <a:defRPr sz="1000" b="1">
-                <a:solidFill>
-                  <a:srgbClr val="212529"/>
+                  <a:srgbClr val="0F172A"/>
                 </a:solidFill>
               </a:defRPr>
             </a:pPr>
             <a:r>
-              <a:t>• Sesgo potencial: </a:t>
-            </a:r>
-            <a:r>
-              <a:rPr b="0" sz="950">
-                <a:solidFill>
-                  <a:srgbClr val="6C757D"/>
-                </a:solidFill>
-              </a:rPr>
-              <a:t>Subrepresenta programas vespertinos y convalidaciones (patrón MAR).</a:t>
-            </a:r>
-          </a:p>
-          <a:p>
-            <a:pPr>
-              <a:defRPr sz="1000" b="1">
-                <a:solidFill>
-                  <a:srgbClr val="212529"/>
-                </a:solidFill>
-              </a:defRPr>
-            </a:pPr>
-            <a:r>
-              <a:t>• Odds Ratios: </a:t>
-            </a:r>
-            <a:r>
-              <a:rPr b="0" sz="950">
-                <a:solidFill>
-                  <a:srgbClr val="6C757D"/>
-                </a:solidFill>
-              </a:rPr>
-              <a:t>Signos preservados pero intervalos más anchos por menor n.</a:t>
-            </a:r>
-          </a:p>
-          <a:p>
-            <a:pPr>
-              <a:defRPr sz="1000" b="1">
-                <a:solidFill>
-                  <a:srgbClr val="212529"/>
-                </a:solidFill>
-              </a:defRPr>
-            </a:pPr>
-            <a:r>
-              <a:t>• Veredicto: </a:t>
-            </a:r>
-            <a:r>
-              <a:rPr b="0" sz="950">
-                <a:solidFill>
-                  <a:srgbClr val="6C757D"/>
-                </a:solidFill>
-              </a:rPr>
-              <a:t>Inconveniente para políticas institucionales integrales.</a:t>
+              <a:t>• Inadmisibilidad de E2: La mediana dio vuelta el signo de 3 jornadas y de Educación, inflando el riesgo al 80-100% en carreras cortas.</a:t>
             </a:r>
           </a:p>
         </p:txBody>
@@ -4762,18 +5792,18 @@
         </p:nvSpPr>
         <p:spPr>
           <a:xfrm>
-            <a:off x="4389120" y="1463040"/>
-            <a:ext cx="3337560" cy="4846320"/>
+            <a:off x="6217920" y="3749039"/>
+            <a:ext cx="5212080" cy="2560320"/>
           </a:xfrm>
           <a:prstGeom prst="roundRect">
             <a:avLst/>
           </a:prstGeom>
           <a:solidFill>
-            <a:srgbClr val="F8F9FB"/>
+            <a:srgbClr val="FFFFFF"/>
           </a:solidFill>
-          <a:ln w="12700">
+          <a:ln>
             <a:solidFill>
-              <a:srgbClr val="6C757D"/>
+              <a:srgbClr val="E2E8F0"/>
             </a:solidFill>
           </a:ln>
         </p:spPr>
@@ -4792,258 +5822,63 @@
           </a:fontRef>
         </p:style>
         <p:txBody>
-          <a:bodyPr rtlCol="0" anchor="ctr" wrap="square" lIns="228600" rIns="228600" tIns="274320"/>
+          <a:bodyPr rtlCol="0" anchor="ctr" wrap="square" lIns="228600" tIns="228600" rIns="228600"/>
           <a:lstStyle/>
           <a:p>
             <a:pPr algn="ctr">
-              <a:defRPr sz="1400" b="1">
+              <a:defRPr sz="1300" b="1">
                 <a:solidFill>
-                  <a:srgbClr val="1A2C4C"/>
+                  <a:srgbClr val="15803D"/>
                 </a:solidFill>
               </a:defRPr>
             </a:pPr>
             <a:r>
-              <a:t>2. Imputación Simple</a:t>
+              <a:t>Solución: Imputación Múltiple Congeniada (MI)</a:t>
             </a:r>
           </a:p>
           <a:p>
             <a:pPr>
-              <a:defRPr sz="950" b="1">
+              <a:spcBef>
+                <a:spcPts val="400"/>
+              </a:spcBef>
+              <a:defRPr sz="1000">
                 <a:solidFill>
-                  <a:srgbClr val="6C757D"/>
+                  <a:srgbClr val="0F172A"/>
                 </a:solidFill>
               </a:defRPr>
             </a:pPr>
             <a:r>
-              <a:t>Mediana condicionada · n = 105.063 (100 %)</a:t>
-            </a:r>
-          </a:p>
-          <a:p/>
+              <a:t>• Modelo Congeniado: Se re-imputó incorporando jornada, sexo y edad con m=20 conjuntos generados por muestreo bayesiano de parámetros.</a:t>
+            </a:r>
+          </a:p>
           <a:p>
             <a:pPr>
-              <a:defRPr sz="1000" b="1">
+              <a:spcBef>
+                <a:spcPts val="400"/>
+              </a:spcBef>
+              <a:defRPr sz="1000">
                 <a:solidFill>
-                  <a:srgbClr val="212529"/>
+                  <a:srgbClr val="0F172A"/>
                 </a:solidFill>
               </a:defRPr>
             </a:pPr>
             <a:r>
-              <a:t>• Recuperación: </a:t>
-            </a:r>
-            <a:r>
-              <a:rPr b="0" sz="950">
+              <a:t>• Reglas de Rubin: Combina varianza intra y entre-imputaciones, capturando con rigor la verdadera incertidumbre del dato ausente.</a:t>
+            </a:r>
+          </a:p>
+          <a:p>
+            <a:pPr>
+              <a:spcBef>
+                <a:spcPts val="400"/>
+              </a:spcBef>
+              <a:defRPr sz="1000">
                 <a:solidFill>
-                  <a:srgbClr val="6C757D"/>
-                </a:solidFill>
-              </a:rPr>
-              <a:t>Recupera todas las filas faltantes.</a:t>
-            </a:r>
-          </a:p>
-          <a:p>
-            <a:pPr>
-              <a:defRPr sz="1000" b="1">
-                <a:solidFill>
-                  <a:srgbClr val="212529"/>
+                  <a:srgbClr val="0F172A"/>
                 </a:solidFill>
               </a:defRPr>
             </a:pPr>
             <a:r>
-              <a:t>• Distorsión: </a:t>
-            </a:r>
-            <a:r>
-              <a:rPr b="0" sz="950">
-                <a:solidFill>
-                  <a:srgbClr val="6C757D"/>
-                </a:solidFill>
-              </a:rPr>
-              <a:t>Comprime artificialmente la varianza e infla la precisión estadística.</a:t>
-            </a:r>
-          </a:p>
-          <a:p>
-            <a:pPr>
-              <a:defRPr sz="1000" b="1">
-                <a:solidFill>
-                  <a:srgbClr val="212529"/>
-                </a:solidFill>
-              </a:defRPr>
-            </a:pPr>
-            <a:r>
-              <a:t>• Correlaciones: </a:t>
-            </a:r>
-            <a:r>
-              <a:rPr b="0" sz="950">
-                <a:solidFill>
-                  <a:srgbClr val="6C757D"/>
-                </a:solidFill>
-              </a:rPr>
-              <a:t>Atenúa la covarianza natural atraso-edad.</a:t>
-            </a:r>
-          </a:p>
-          <a:p>
-            <a:pPr>
-              <a:defRPr sz="1000" b="1">
-                <a:solidFill>
-                  <a:srgbClr val="212529"/>
-                </a:solidFill>
-              </a:defRPr>
-            </a:pPr>
-            <a:r>
-              <a:t>• Veredicto: </a:t>
-            </a:r>
-            <a:r>
-              <a:rPr b="0" sz="950">
-                <a:solidFill>
-                  <a:srgbClr val="6C757D"/>
-                </a:solidFill>
-              </a:rPr>
-              <a:t>Riesgo de subestimar el error estándar real.</a:t>
-            </a:r>
-          </a:p>
-        </p:txBody>
-      </p:sp>
-      <p:sp>
-        <p:nvSpPr>
-          <p:cNvPr id="7" name="Rounded Rectangle 6"/>
-          <p:cNvSpPr/>
-          <p:nvPr/>
-        </p:nvSpPr>
-        <p:spPr>
-          <a:xfrm>
-            <a:off x="8046720" y="1463040"/>
-            <a:ext cx="3337560" cy="4846320"/>
-          </a:xfrm>
-          <a:prstGeom prst="roundRect">
-            <a:avLst/>
-          </a:prstGeom>
-          <a:solidFill>
-            <a:srgbClr val="F8F9FB"/>
-          </a:solidFill>
-          <a:ln w="25400">
-            <a:solidFill>
-              <a:srgbClr val="A6192E"/>
-            </a:solidFill>
-          </a:ln>
-        </p:spPr>
-        <p:style>
-          <a:lnRef idx="1">
-            <a:schemeClr val="accent1"/>
-          </a:lnRef>
-          <a:fillRef idx="3">
-            <a:schemeClr val="accent1"/>
-          </a:fillRef>
-          <a:effectRef idx="2">
-            <a:schemeClr val="accent1"/>
-          </a:effectRef>
-          <a:fontRef idx="minor">
-            <a:schemeClr val="lt1"/>
-          </a:fontRef>
-        </p:style>
-        <p:txBody>
-          <a:bodyPr rtlCol="0" anchor="ctr" wrap="square" lIns="228600" rIns="228600" tIns="274320"/>
-          <a:lstStyle/>
-          <a:p>
-            <a:pPr algn="ctr">
-              <a:defRPr sz="1400" b="1">
-                <a:solidFill>
-                  <a:srgbClr val="1A2C4C"/>
-                </a:solidFill>
-              </a:defRPr>
-            </a:pPr>
-            <a:r>
-              <a:t>3. Regresión Múltiple</a:t>
-            </a:r>
-          </a:p>
-          <a:p>
-            <a:pPr>
-              <a:defRPr sz="950" b="1">
-                <a:solidFill>
-                  <a:srgbClr val="A6192E"/>
-                </a:solidFill>
-              </a:defRPr>
-            </a:pPr>
-            <a:r>
-              <a:t>Imputación inteligente · n = 105.063 (100 %)</a:t>
-            </a:r>
-          </a:p>
-          <a:p/>
-          <a:p>
-            <a:pPr>
-              <a:defRPr sz="1000" b="1">
-                <a:solidFill>
-                  <a:srgbClr val="212529"/>
-                </a:solidFill>
-              </a:defRPr>
-            </a:pPr>
-            <a:r>
-              <a:t>• Fundamento S1/S2: </a:t>
-            </a:r>
-            <a:r>
-              <a:rPr b="0" sz="950">
-                <a:solidFill>
-                  <a:srgbClr val="6C757D"/>
-                </a:solidFill>
-              </a:rPr>
-              <a:t>Usa predictores con correlación robusta (edad, duración, área, jornada).</a:t>
-            </a:r>
-          </a:p>
-          <a:p>
-            <a:pPr>
-              <a:defRPr sz="1000" b="1">
-                <a:solidFill>
-                  <a:srgbClr val="212529"/>
-                </a:solidFill>
-              </a:defRPr>
-            </a:pPr>
-            <a:r>
-              <a:t>• Covarianza: </a:t>
-            </a:r>
-            <a:r>
-              <a:rPr b="0" sz="950">
-                <a:solidFill>
-                  <a:srgbClr val="6C757D"/>
-                </a:solidFill>
-              </a:rPr>
-              <a:t>Preserva la estructura multivariada de los datos.</a:t>
-            </a:r>
-          </a:p>
-          <a:p>
-            <a:pPr>
-              <a:defRPr sz="1000" b="1">
-                <a:solidFill>
-                  <a:srgbClr val="212529"/>
-                </a:solidFill>
-              </a:defRPr>
-            </a:pPr>
-            <a:r>
-              <a:t>• Desempeño Test: </a:t>
-            </a:r>
-            <a:r>
-              <a:rPr b="0" sz="950">
-                <a:solidFill>
-                  <a:srgbClr val="6C757D"/>
-                </a:solidFill>
-              </a:rPr>
-              <a:t>Mantiene alta capacidad predictiva (AUC sólido en Test).</a:t>
-            </a:r>
-          </a:p>
-          <a:p>
-            <a:pPr>
-              <a:defRPr sz="1000" b="1">
-                <a:solidFill>
-                  <a:srgbClr val="212529"/>
-                </a:solidFill>
-              </a:defRPr>
-            </a:pPr>
-            <a:r>
-              <a:t>• Veredicto: </a:t>
-            </a:r>
-            <a:r>
-              <a:rPr b="0" sz="950">
-                <a:solidFill>
-                  <a:srgbClr val="6C757D"/>
-                </a:solidFill>
-              </a:rPr>
-              <a:t>Estrategia recomendada: máxima potencia sin sesgo.</a:t>
+              <a:t>• Corrección de la Distorsión: La discrepancia media con E1 cayó de 18,5% a solo 7,3%, Diurna bajó a OR = 1,60 y Semipresencial retornó a 0,62 (protector).</a:t>
             </a:r>
           </a:p>
         </p:txBody>
@@ -5068,14 +5903,57 @@
       <p:grpSpPr/>
       <p:sp>
         <p:nvSpPr>
-          <p:cNvPr id="2" name="TextBox 1"/>
+          <p:cNvPr id="2" name="Rectangle 1"/>
+          <p:cNvSpPr/>
+          <p:nvPr/>
+        </p:nvSpPr>
+        <p:spPr>
+          <a:xfrm>
+            <a:off x="0" y="0"/>
+            <a:ext cx="12191695" cy="6858000"/>
+          </a:xfrm>
+          <a:prstGeom prst="rect">
+            <a:avLst/>
+          </a:prstGeom>
+          <a:solidFill>
+            <a:srgbClr val="F8FAFC"/>
+          </a:solidFill>
+          <a:ln>
+            <a:noFill/>
+          </a:ln>
+        </p:spPr>
+        <p:style>
+          <a:lnRef idx="1">
+            <a:schemeClr val="accent1"/>
+          </a:lnRef>
+          <a:fillRef idx="3">
+            <a:schemeClr val="accent1"/>
+          </a:fillRef>
+          <a:effectRef idx="2">
+            <a:schemeClr val="accent1"/>
+          </a:effectRef>
+          <a:fontRef idx="minor">
+            <a:schemeClr val="lt1"/>
+          </a:fontRef>
+        </p:style>
+        <p:txBody>
+          <a:bodyPr rtlCol="0" anchor="ctr"/>
+          <a:lstStyle/>
+          <a:p>
+            <a:pPr algn="ctr"/>
+          </a:p>
+        </p:txBody>
+      </p:sp>
+      <p:sp>
+        <p:nvSpPr>
+          <p:cNvPr id="3" name="TextBox 2"/>
           <p:cNvSpPr txBox="1"/>
           <p:nvPr/>
         </p:nvSpPr>
         <p:spPr>
           <a:xfrm>
             <a:off x="731520" y="365760"/>
-            <a:ext cx="9144000" cy="365760"/>
+            <a:ext cx="10698480" cy="1005840"/>
           </a:xfrm>
           <a:prstGeom prst="rect">
             <a:avLst/>
@@ -5083,7 +5961,7 @@
           <a:noFill/>
         </p:spPr>
         <p:txBody>
-          <a:bodyPr wrap="square">
+          <a:bodyPr wrap="square" lIns="0" tIns="0" rIns="0" bIns="0">
             <a:spAutoFit/>
           </a:bodyPr>
           <a:lstStyle/>
@@ -5091,95 +5969,51 @@
             <a:pPr>
               <a:defRPr sz="1000" b="1">
                 <a:solidFill>
-                  <a:srgbClr val="A6192E"/>
+                  <a:srgbClr val="1E40AF"/>
                 </a:solidFill>
               </a:defRPr>
             </a:pPr>
             <a:r>
-              <a:t>SUMATIVA 3 · BLOQUE 4 · SEBASTIÁN CAJALES</a:t>
-            </a:r>
-          </a:p>
-        </p:txBody>
-      </p:sp>
-      <p:sp>
-        <p:nvSpPr>
-          <p:cNvPr id="3" name="TextBox 2"/>
-          <p:cNvSpPr txBox="1"/>
-          <p:nvPr/>
-        </p:nvSpPr>
-        <p:spPr>
-          <a:xfrm>
-            <a:off x="731520" y="640080"/>
-            <a:ext cx="9326880" cy="731520"/>
-          </a:xfrm>
-          <a:prstGeom prst="rect">
-            <a:avLst/>
-          </a:prstGeom>
-          <a:noFill/>
-        </p:spPr>
-        <p:txBody>
-          <a:bodyPr wrap="square">
-            <a:spAutoFit/>
-          </a:bodyPr>
-          <a:lstStyle/>
+              <a:t>BLOQUE 4 · SÍNTESIS S1 -&gt; S2 -&gt; S3 Y TOMA DE DECISIONES</a:t>
+            </a:r>
+          </a:p>
           <a:p>
             <a:pPr>
+              <a:spcBef>
+                <a:spcPts val="400"/>
+              </a:spcBef>
               <a:defRPr sz="2200" b="1">
                 <a:solidFill>
-                  <a:srgbClr val="1A2C4C"/>
+                  <a:srgbClr val="0F172A"/>
                 </a:solidFill>
               </a:defRPr>
             </a:pPr>
             <a:r>
-              <a:t>Progresión Metodológica Integrada: S1 → S2 → S3</a:t>
-            </a:r>
-          </a:p>
-        </p:txBody>
-      </p:sp>
-      <p:pic>
-        <p:nvPicPr>
-          <p:cNvPr id="4" name="Picture 3" descr="logo_unab_color.png"/>
-          <p:cNvPicPr>
-            <a:picLocks noChangeAspect="1"/>
-          </p:cNvPicPr>
+              <a:t>Cadena Metodológica Acumulativa y Recomendaciones Directivas</a:t>
+            </a:r>
+          </a:p>
+        </p:txBody>
+      </p:sp>
+      <p:sp>
+        <p:nvSpPr>
+          <p:cNvPr id="4" name="Rounded Rectangle 3"/>
+          <p:cNvSpPr/>
           <p:nvPr/>
-        </p:nvPicPr>
-        <p:blipFill>
-          <a:blip r:embed="rId2"/>
-          <a:stretch>
-            <a:fillRect/>
-          </a:stretch>
-        </p:blipFill>
+        </p:nvSpPr>
         <p:spPr>
           <a:xfrm>
-            <a:off x="10332720" y="320040"/>
-            <a:ext cx="1033134" cy="868680"/>
-          </a:xfrm>
-          <a:prstGeom prst="rect">
-            <a:avLst/>
-          </a:prstGeom>
-        </p:spPr>
-      </p:pic>
-      <p:sp>
-        <p:nvSpPr>
-          <p:cNvPr id="5" name="Rounded Rectangle 4"/>
-          <p:cNvSpPr/>
-          <p:nvPr/>
-        </p:nvSpPr>
-        <p:spPr>
-          <a:xfrm>
-            <a:off x="731520" y="1371600"/>
-            <a:ext cx="10698480" cy="1508760"/>
+            <a:off x="731520" y="1463040"/>
+            <a:ext cx="5120640" cy="4846320"/>
           </a:xfrm>
           <a:prstGeom prst="roundRect">
             <a:avLst/>
           </a:prstGeom>
           <a:solidFill>
-            <a:srgbClr val="F8F9FB"/>
+            <a:srgbClr val="FFFFFF"/>
           </a:solidFill>
           <a:ln>
             <a:solidFill>
-              <a:srgbClr val="DEE2E6"/>
+              <a:srgbClr val="E2E8F0"/>
             </a:solidFill>
           </a:ln>
         </p:spPr>
@@ -5198,90 +6032,132 @@
           </a:fontRef>
         </p:style>
         <p:txBody>
-          <a:bodyPr rtlCol="0" anchor="ctr" wrap="square" lIns="274320" tIns="164592"/>
+          <a:bodyPr rtlCol="0" anchor="ctr" wrap="square" lIns="274320" tIns="274320" rIns="274320"/>
           <a:lstStyle/>
           <a:p>
             <a:pPr algn="ctr">
-              <a:defRPr sz="1300" b="1">
+              <a:defRPr sz="1500" b="1">
                 <a:solidFill>
-                  <a:srgbClr val="1A2C4C"/>
+                  <a:srgbClr val="1E40AF"/>
                 </a:solidFill>
               </a:defRPr>
             </a:pPr>
             <a:r>
-              <a:t>Fase 1: Sumativa 1  |  Diagnóstico Exploratorio e Inferencia</a:t>
+              <a:t>Progresión Acumulativa (S1 -&gt; S2 -&gt; S3)</a:t>
             </a:r>
           </a:p>
           <a:p>
             <a:pPr>
-              <a:defRPr sz="950">
+              <a:spcBef>
+                <a:spcPts val="800"/>
+              </a:spcBef>
+              <a:defRPr sz="1100" b="1">
                 <a:solidFill>
-                  <a:srgbClr val="212529"/>
+                  <a:srgbClr val="0F172A"/>
                 </a:solidFill>
               </a:defRPr>
             </a:pPr>
             <a:r>
-              <a:t>• Identificación de 12,75 % de faltantes administrativos (1900/0 en ingreso original).</a:t>
+              <a:t>Sumativa 1 (Fase 2): Calidad y Exploración</a:t>
             </a:r>
           </a:p>
           <a:p>
             <a:pPr>
-              <a:defRPr sz="950">
+              <a:spcBef>
+                <a:spcPts val="200"/>
+              </a:spcBef>
+              <a:defRPr sz="1000">
                 <a:solidFill>
-                  <a:srgbClr val="212529"/>
+                  <a:srgbClr val="64748B"/>
                 </a:solidFill>
               </a:defRPr>
             </a:pPr>
             <a:r>
-              <a:t>• Atraso medio de 3,4 semestres con fuerte asimetría positiva (mediana = 2).</a:t>
+              <a:t>Aislamiento de códigos centinela (12,75% faltantes MAR), retención fundada de 3.201 atípicos Tukey y asimetría positiva del atraso.</a:t>
             </a:r>
           </a:p>
           <a:p>
             <a:pPr>
-              <a:defRPr sz="950">
+              <a:spcBef>
+                <a:spcPts val="800"/>
+              </a:spcBef>
+              <a:defRPr sz="1100" b="1">
                 <a:solidFill>
-                  <a:srgbClr val="212529"/>
+                  <a:srgbClr val="0F172A"/>
                 </a:solidFill>
               </a:defRPr>
             </a:pPr>
             <a:r>
-              <a:t>• Correlación moderada atraso-edad (rho = 0,47) y brechas iniciales por sexo y jornada.</a:t>
+              <a:t>Sumativa 2 (Fase 3): Validación por Remuestreo</a:t>
             </a:r>
           </a:p>
           <a:p>
             <a:pPr>
-              <a:defRPr sz="950">
+              <a:spcBef>
+                <a:spcPts val="200"/>
+              </a:spcBef>
+              <a:defRPr sz="1000">
                 <a:solidFill>
-                  <a:srgbClr val="212529"/>
+                  <a:srgbClr val="64748B"/>
                 </a:solidFill>
               </a:defRPr>
             </a:pPr>
             <a:r>
-              <a:t>• Detección de 13.201 atípicos según Tukey (decisión clave: conservarlos).</a:t>
-            </a:r>
-          </a:p>
-        </p:txBody>
-      </p:sp>
-      <p:sp>
-        <p:nvSpPr>
-          <p:cNvPr id="6" name="Rounded Rectangle 5"/>
+              <a:t>Bootstrap BCa demostró que el área curricular media la brecha de género (de +1,07 a +0,55 semestres) y Jackknife descubrió la fuerte dependencia institucional.</a:t>
+            </a:r>
+          </a:p>
+          <a:p>
+            <a:pPr>
+              <a:spcBef>
+                <a:spcPts val="800"/>
+              </a:spcBef>
+              <a:defRPr sz="1100" b="1">
+                <a:solidFill>
+                  <a:srgbClr val="0F172A"/>
+                </a:solidFill>
+              </a:defRPr>
+            </a:pPr>
+            <a:r>
+              <a:t>Sumativa 3 (Fase 4): Modelamiento e Integración</a:t>
+            </a:r>
+          </a:p>
+          <a:p>
+            <a:pPr>
+              <a:spcBef>
+                <a:spcPts val="200"/>
+              </a:spcBef>
+              <a:defRPr sz="1000">
+                <a:solidFill>
+                  <a:srgbClr val="64748B"/>
+                </a:solidFill>
+              </a:defRPr>
+            </a:pPr>
+            <a:r>
+              <a:t>Imputación multivariada informada, regresión logística con selección parsimoniosa (M2), auditoría de no-congenialidad e inferencia clúster.</a:t>
+            </a:r>
+          </a:p>
+        </p:txBody>
+      </p:sp>
+      <p:sp>
+        <p:nvSpPr>
+          <p:cNvPr id="5" name="Rounded Rectangle 4"/>
           <p:cNvSpPr/>
           <p:nvPr/>
         </p:nvSpPr>
         <p:spPr>
           <a:xfrm>
-            <a:off x="731520" y="3063240"/>
-            <a:ext cx="10698480" cy="1508760"/>
+            <a:off x="6217920" y="1463040"/>
+            <a:ext cx="5212080" cy="4846320"/>
           </a:xfrm>
           <a:prstGeom prst="roundRect">
             <a:avLst/>
           </a:prstGeom>
           <a:solidFill>
-            <a:srgbClr val="F8F9FB"/>
+            <a:srgbClr val="FFFFFF"/>
           </a:solidFill>
           <a:ln>
             <a:solidFill>
-              <a:srgbClr val="DEE2E6"/>
+              <a:srgbClr val="E2E8F0"/>
             </a:solidFill>
           </a:ln>
         </p:spPr>
@@ -5300,168 +6176,108 @@
           </a:fontRef>
         </p:style>
         <p:txBody>
-          <a:bodyPr rtlCol="0" anchor="ctr" wrap="square" lIns="274320" tIns="164592"/>
+          <a:bodyPr rtlCol="0" anchor="ctr" wrap="square" lIns="274320" tIns="274320" rIns="274320"/>
           <a:lstStyle/>
           <a:p>
             <a:pPr algn="ctr">
-              <a:defRPr sz="1300" b="1">
+              <a:defRPr sz="1500" b="1">
                 <a:solidFill>
-                  <a:srgbClr val="1A2C4C"/>
+                  <a:srgbClr val="15803D"/>
                 </a:solidFill>
               </a:defRPr>
             </a:pPr>
             <a:r>
-              <a:t>Fase 2: Sumativa 2  |  Validación Computacional y Remuestreo</a:t>
+              <a:t>Recomendaciones Estratégicas para la Gestión</a:t>
             </a:r>
           </a:p>
           <a:p>
             <a:pPr>
-              <a:defRPr sz="950">
+              <a:spcBef>
+                <a:spcPts val="800"/>
+              </a:spcBef>
+              <a:defRPr sz="1100" b="1">
                 <a:solidFill>
-                  <a:srgbClr val="212529"/>
+                  <a:srgbClr val="0F172A"/>
                 </a:solidFill>
               </a:defRPr>
             </a:pPr>
             <a:r>
-              <a:t>• Bootstrap BCa (B = 10.000): Correlaciones son auténticamente estables y lineales.</a:t>
+              <a:t>1. Sistemas de Alerta Temprana Diferenciados por Área</a:t>
             </a:r>
           </a:p>
           <a:p>
             <a:pPr>
-              <a:defRPr sz="950">
+              <a:spcBef>
+                <a:spcPts val="200"/>
+              </a:spcBef>
+              <a:defRPr sz="1000">
                 <a:solidFill>
-                  <a:srgbClr val="212529"/>
+                  <a:srgbClr val="64748B"/>
                 </a:solidFill>
               </a:defRPr>
             </a:pPr>
             <a:r>
-              <a:t>• Análisis de Robustez: Atípicos afectan magnitud de colas pero no alteran la dirección.</a:t>
+              <a:t>Focalizar tutorías y recursos de egreso en carreras de Derecho (OR = 4,42), Ingeniería y Tecnología (OR = 2,14) y Ciencias Básicas (OR = 2,03), donde los cuellos de botella de titulación son estructurales y no explicables por variables basales.</a:t>
             </a:r>
           </a:p>
           <a:p>
             <a:pPr>
-              <a:defRPr sz="950">
+              <a:spcBef>
+                <a:spcPts val="800"/>
+              </a:spcBef>
+              <a:defRPr sz="1100" b="1">
                 <a:solidFill>
-                  <a:srgbClr val="212529"/>
+                  <a:srgbClr val="0F172A"/>
                 </a:solidFill>
               </a:defRPr>
             </a:pPr>
             <a:r>
-              <a:t>• Jackknife por Institución: Evidenció dependencia jerárquica intra-universidad.</a:t>
+              <a:t>2. Regulación y Flexibilización de Plazos de Gratuidad</a:t>
             </a:r>
           </a:p>
           <a:p>
             <a:pPr>
-              <a:defRPr sz="950">
+              <a:spcBef>
+                <a:spcPts val="200"/>
+              </a:spcBef>
+              <a:defRPr sz="1000">
                 <a:solidFill>
-                  <a:srgbClr val="212529"/>
+                  <a:srgbClr val="64748B"/>
                 </a:solidFill>
               </a:defRPr>
             </a:pPr>
             <a:r>
-              <a:t>• Efecto Simpson: La brecha por sexo se reduce a la mitad al controlar por área.</a:t>
-            </a:r>
-          </a:p>
-        </p:txBody>
-      </p:sp>
-      <p:sp>
-        <p:nvSpPr>
-          <p:cNvPr id="7" name="Rounded Rectangle 6"/>
-          <p:cNvSpPr/>
-          <p:nvPr/>
-        </p:nvSpPr>
-        <p:spPr>
-          <a:xfrm>
-            <a:off x="731520" y="4754880"/>
-            <a:ext cx="10698480" cy="1508760"/>
-          </a:xfrm>
-          <a:prstGeom prst="roundRect">
-            <a:avLst/>
-          </a:prstGeom>
-          <a:solidFill>
-            <a:srgbClr val="F8F9FB"/>
-          </a:solidFill>
-          <a:ln>
-            <a:solidFill>
-              <a:srgbClr val="DEE2E6"/>
-            </a:solidFill>
-          </a:ln>
-        </p:spPr>
-        <p:style>
-          <a:lnRef idx="1">
-            <a:schemeClr val="accent1"/>
-          </a:lnRef>
-          <a:fillRef idx="3">
-            <a:schemeClr val="accent1"/>
-          </a:fillRef>
-          <a:effectRef idx="2">
-            <a:schemeClr val="accent1"/>
-          </a:effectRef>
-          <a:fontRef idx="minor">
-            <a:schemeClr val="lt1"/>
-          </a:fontRef>
-        </p:style>
-        <p:txBody>
-          <a:bodyPr rtlCol="0" anchor="ctr" wrap="square" lIns="274320" tIns="164592"/>
-          <a:lstStyle/>
-          <a:p>
-            <a:pPr algn="ctr">
-              <a:defRPr sz="1300" b="1">
+              <a:t>Casi un 25% del estudiantado sufre atraso severo (&gt;4 semestres). El límite estricto de gratuidad a la duración nominal empuja a la deserción terminal y sobreendeudamiento; se requiere cobertura proporcional regulada.</a:t>
+            </a:r>
+          </a:p>
+          <a:p>
+            <a:pPr>
+              <a:spcBef>
+                <a:spcPts val="800"/>
+              </a:spcBef>
+              <a:defRPr sz="1100" b="1">
                 <a:solidFill>
-                  <a:srgbClr val="A6192E"/>
+                  <a:srgbClr val="0F172A"/>
                 </a:solidFill>
               </a:defRPr>
             </a:pPr>
             <a:r>
-              <a:t>Fase 3: Sumativa 3  |  Modelamiento Predictivo y Robustez</a:t>
+              <a:t>3. Rigor Metodológico en Analítica Institucional</a:t>
             </a:r>
           </a:p>
           <a:p>
             <a:pPr>
-              <a:defRPr sz="950">
+              <a:spcBef>
+                <a:spcPts val="200"/>
+              </a:spcBef>
+              <a:defRPr sz="1000">
                 <a:solidFill>
-                  <a:srgbClr val="212529"/>
+                  <a:srgbClr val="64748B"/>
                 </a:solidFill>
               </a:defRPr>
             </a:pPr>
             <a:r>
-              <a:t>• Imputación por Regresión: Recupera los 13.396 casos basándose en correlaciones de S1/S2.</a:t>
-            </a:r>
-          </a:p>
-          <a:p>
-            <a:pPr>
-              <a:defRPr sz="950">
-                <a:solidFill>
-                  <a:srgbClr val="212529"/>
-                </a:solidFill>
-              </a:defRPr>
-            </a:pPr>
-            <a:r>
-              <a:t>• Regresión Logística: Clasificación supervisada de 'Atraso Alto' (&gt; 4 semestres).</a:t>
-            </a:r>
-          </a:p>
-          <a:p>
-            <a:pPr>
-              <a:defRPr sz="950">
-                <a:solidFill>
-                  <a:srgbClr val="212529"/>
-                </a:solidFill>
-              </a:defRPr>
-            </a:pPr>
-            <a:r>
-              <a:t>• Bootstrap del Modelo: IC al 95 % confirman estabilidad de Odds Ratios sin asunciones asintóticas.</a:t>
-            </a:r>
-          </a:p>
-          <a:p>
-            <a:pPr>
-              <a:defRPr sz="950">
-                <a:solidFill>
-                  <a:srgbClr val="212529"/>
-                </a:solidFill>
-              </a:defRPr>
-            </a:pPr>
-            <a:r>
-              <a:t>• Evaluación de Impacto: La imputación robustece la precisión sin alterar la política.</a:t>
+              <a:t>Prohibir la imputación simple en sistemas de retención universitaria; exigir siempre imputación múltiple congeniada y ajustar la inferencia por la estructura clúster de las instituciones.</a:t>
             </a:r>
           </a:p>
         </p:txBody>
@@ -5486,119 +6302,23 @@
       <p:grpSpPr/>
       <p:sp>
         <p:nvSpPr>
-          <p:cNvPr id="2" name="TextBox 1"/>
-          <p:cNvSpPr txBox="1"/>
+          <p:cNvPr id="2" name="Rectangle 1"/>
+          <p:cNvSpPr/>
           <p:nvPr/>
         </p:nvSpPr>
         <p:spPr>
           <a:xfrm>
-            <a:off x="731520" y="365760"/>
-            <a:ext cx="9144000" cy="365760"/>
+            <a:off x="0" y="0"/>
+            <a:ext cx="12191695" cy="6858000"/>
           </a:xfrm>
           <a:prstGeom prst="rect">
             <a:avLst/>
           </a:prstGeom>
-          <a:noFill/>
-        </p:spPr>
-        <p:txBody>
-          <a:bodyPr wrap="square">
-            <a:spAutoFit/>
-          </a:bodyPr>
-          <a:lstStyle/>
-          <a:p>
-            <a:pPr>
-              <a:defRPr sz="1000" b="1">
-                <a:solidFill>
-                  <a:srgbClr val="A6192E"/>
-                </a:solidFill>
-              </a:defRPr>
-            </a:pPr>
-            <a:r>
-              <a:t>SUMATIVA 3 · BLOQUE 4 · SEBASTIÁN CAJALES</a:t>
-            </a:r>
-          </a:p>
-        </p:txBody>
-      </p:sp>
-      <p:sp>
-        <p:nvSpPr>
-          <p:cNvPr id="3" name="TextBox 2"/>
-          <p:cNvSpPr txBox="1"/>
-          <p:nvPr/>
-        </p:nvSpPr>
-        <p:spPr>
-          <a:xfrm>
-            <a:off x="731520" y="640080"/>
-            <a:ext cx="9326880" cy="731520"/>
-          </a:xfrm>
-          <a:prstGeom prst="rect">
-            <a:avLst/>
-          </a:prstGeom>
-          <a:noFill/>
-        </p:spPr>
-        <p:txBody>
-          <a:bodyPr wrap="square">
-            <a:spAutoFit/>
-          </a:bodyPr>
-          <a:lstStyle/>
-          <a:p>
-            <a:pPr>
-              <a:defRPr sz="2200" b="1">
-                <a:solidFill>
-                  <a:srgbClr val="1A2C4C"/>
-                </a:solidFill>
-              </a:defRPr>
-            </a:pPr>
-            <a:r>
-              <a:t>Recomendaciones Estratégicas para la Toma de Decisiones</a:t>
-            </a:r>
-          </a:p>
-        </p:txBody>
-      </p:sp>
-      <p:pic>
-        <p:nvPicPr>
-          <p:cNvPr id="4" name="Picture 3" descr="logo_unab_color.png"/>
-          <p:cNvPicPr>
-            <a:picLocks noChangeAspect="1"/>
-          </p:cNvPicPr>
-          <p:nvPr/>
-        </p:nvPicPr>
-        <p:blipFill>
-          <a:blip r:embed="rId2"/>
-          <a:stretch>
-            <a:fillRect/>
-          </a:stretch>
-        </p:blipFill>
-        <p:spPr>
-          <a:xfrm>
-            <a:off x="10332720" y="320040"/>
-            <a:ext cx="1033134" cy="868680"/>
-          </a:xfrm>
-          <a:prstGeom prst="rect">
-            <a:avLst/>
-          </a:prstGeom>
-        </p:spPr>
-      </p:pic>
-      <p:sp>
-        <p:nvSpPr>
-          <p:cNvPr id="5" name="Rounded Rectangle 4"/>
-          <p:cNvSpPr/>
-          <p:nvPr/>
-        </p:nvSpPr>
-        <p:spPr>
-          <a:xfrm>
-            <a:off x="731520" y="1463040"/>
-            <a:ext cx="5120640" cy="3840480"/>
-          </a:xfrm>
-          <a:prstGeom prst="roundRect">
-            <a:avLst/>
-          </a:prstGeom>
           <a:solidFill>
-            <a:srgbClr val="F8F9FB"/>
+            <a:srgbClr val="0F2043"/>
           </a:solidFill>
-          <a:ln w="19050">
-            <a:solidFill>
-              <a:srgbClr val="1A2C4C"/>
-            </a:solidFill>
+          <a:ln>
+            <a:noFill/>
           </a:ln>
         </p:spPr>
         <p:style>
@@ -5616,166 +6336,23 @@
           </a:fontRef>
         </p:style>
         <p:txBody>
-          <a:bodyPr rtlCol="0" anchor="ctr" wrap="square" lIns="365760" rIns="365760" tIns="365760"/>
+          <a:bodyPr rtlCol="0" anchor="ctr"/>
           <a:lstStyle/>
           <a:p>
-            <a:pPr algn="ctr">
-              <a:defRPr sz="1600" b="1">
-                <a:solidFill>
-                  <a:srgbClr val="1A2C4C"/>
-                </a:solidFill>
-              </a:defRPr>
-            </a:pPr>
-            <a:r>
-              <a:t>1. Sistemas de Alerta Temprana Diferenciados</a:t>
-            </a:r>
-          </a:p>
-          <a:p>
-            <a:pPr>
-              <a:defRPr sz="1100" b="1">
-                <a:solidFill>
-                  <a:srgbClr val="212529"/>
-                </a:solidFill>
-              </a:defRPr>
-            </a:pPr>
-            <a:r>
-              <a:t>• Focalización Curricular: </a:t>
-            </a:r>
-            <a:r>
-              <a:rPr b="0" sz="1050">
-                <a:solidFill>
-                  <a:srgbClr val="6C757D"/>
-                </a:solidFill>
-              </a:rPr>
-              <a:t>El riesgo de atraso severo se concentra intensamente en facultades de Tecnología, Ciencias e Ingeniería. Las tutorías de titulación deben priorizarse en estas áreas.</a:t>
-            </a:r>
-          </a:p>
-          <a:p>
-            <a:pPr>
-              <a:defRPr sz="1100" b="1">
-                <a:solidFill>
-                  <a:srgbClr val="212529"/>
-                </a:solidFill>
-              </a:defRPr>
-            </a:pPr>
-            <a:r>
-              <a:t>• Flexibilidad en Jornada Vespertina: </a:t>
-            </a:r>
-            <a:r>
-              <a:rPr b="0" sz="1050">
-                <a:solidFill>
-                  <a:srgbClr val="6C757D"/>
-                </a:solidFill>
-              </a:rPr>
-              <a:t>La brecha estructural de +9 pp en atraso alto en jornada vespertina exige mecanismos de graduación no presenciales, talleres de tesis en fin de semana y flexibilidad de plazos administrativos.</a:t>
-            </a:r>
-          </a:p>
-        </p:txBody>
-      </p:sp>
-      <p:sp>
-        <p:nvSpPr>
-          <p:cNvPr id="6" name="Rounded Rectangle 5"/>
-          <p:cNvSpPr/>
+            <a:pPr algn="ctr"/>
+          </a:p>
+        </p:txBody>
+      </p:sp>
+      <p:sp>
+        <p:nvSpPr>
+          <p:cNvPr id="3" name="TextBox 2"/>
+          <p:cNvSpPr txBox="1"/>
           <p:nvPr/>
         </p:nvSpPr>
         <p:spPr>
           <a:xfrm>
-            <a:off x="6217920" y="1463040"/>
-            <a:ext cx="5120640" cy="3840480"/>
-          </a:xfrm>
-          <a:prstGeom prst="roundRect">
-            <a:avLst/>
-          </a:prstGeom>
-          <a:solidFill>
-            <a:srgbClr val="F8F9FB"/>
-          </a:solidFill>
-          <a:ln w="19050">
-            <a:solidFill>
-              <a:srgbClr val="A6192E"/>
-            </a:solidFill>
-          </a:ln>
-        </p:spPr>
-        <p:style>
-          <a:lnRef idx="1">
-            <a:schemeClr val="accent1"/>
-          </a:lnRef>
-          <a:fillRef idx="3">
-            <a:schemeClr val="accent1"/>
-          </a:fillRef>
-          <a:effectRef idx="2">
-            <a:schemeClr val="accent1"/>
-          </a:effectRef>
-          <a:fontRef idx="minor">
-            <a:schemeClr val="lt1"/>
-          </a:fontRef>
-        </p:style>
-        <p:txBody>
-          <a:bodyPr rtlCol="0" anchor="ctr" wrap="square" lIns="365760" rIns="365760" tIns="365760"/>
-          <a:lstStyle/>
-          <a:p>
-            <a:pPr algn="ctr">
-              <a:defRPr sz="1600" b="1">
-                <a:solidFill>
-                  <a:srgbClr val="A6192E"/>
-                </a:solidFill>
-              </a:defRPr>
-            </a:pPr>
-            <a:r>
-              <a:t>2. Flexibilización en Gratuidad y Acreditación</a:t>
-            </a:r>
-          </a:p>
-          <a:p>
-            <a:pPr>
-              <a:defRPr sz="1100" b="1">
-                <a:solidFill>
-                  <a:srgbClr val="212529"/>
-                </a:solidFill>
-              </a:defRPr>
-            </a:pPr>
-            <a:r>
-              <a:t>• Revisión de Plazos de Cobertura: </a:t>
-            </a:r>
-            <a:r>
-              <a:rPr b="0" sz="1050">
-                <a:solidFill>
-                  <a:srgbClr val="6C757D"/>
-                </a:solidFill>
-              </a:rPr>
-              <a:t>El atraso superior a 4 semestres es un fenómeno estructural (no un hecho aislado). Los beneficios de gratuidad y becas deben contemplar semestres de gracia ajustados a la tasa real de egreso por carrera.</a:t>
-            </a:r>
-          </a:p>
-          <a:p>
-            <a:pPr>
-              <a:defRPr sz="1100" b="1">
-                <a:solidFill>
-                  <a:srgbClr val="212529"/>
-                </a:solidFill>
-              </a:defRPr>
-            </a:pPr>
-            <a:r>
-              <a:t>• Métricas de Acreditación (CNA): </a:t>
-            </a:r>
-            <a:r>
-              <a:rPr b="0" sz="1050">
-                <a:solidFill>
-                  <a:srgbClr val="6C757D"/>
-                </a:solidFill>
-              </a:rPr>
-              <a:t>Evaluar la sobre-duración considerando la composición de matrícula (jornada vespertina y áreas STEM) para no penalizar a instituciones con poblaciones de mayor complejidad formativa.</a:t>
-            </a:r>
-          </a:p>
-        </p:txBody>
-      </p:sp>
-      <p:sp>
-        <p:nvSpPr>
-          <p:cNvPr id="7" name="TextBox 6"/>
-          <p:cNvSpPr txBox="1"/>
-          <p:nvPr/>
-        </p:nvSpPr>
-        <p:spPr>
-          <a:xfrm>
-            <a:off x="731520" y="5577840"/>
-            <a:ext cx="10698480" cy="731520"/>
+            <a:off x="914400" y="1371600"/>
+            <a:ext cx="10332720" cy="4114800"/>
           </a:xfrm>
           <a:prstGeom prst="rect">
             <a:avLst/>
@@ -5783,20 +6360,92 @@
           <a:noFill/>
         </p:spPr>
         <p:txBody>
-          <a:bodyPr wrap="none">
+          <a:bodyPr wrap="square">
             <a:spAutoFit/>
           </a:bodyPr>
           <a:lstStyle/>
           <a:p>
-            <a:pPr algn="ctr">
+            <a:pPr>
               <a:defRPr sz="1300" b="1">
                 <a:solidFill>
-                  <a:srgbClr val="1A2C4C"/>
+                  <a:srgbClr val="93C5FD"/>
                 </a:solidFill>
               </a:defRPr>
             </a:pPr>
             <a:r>
-              <a:t>¡Muchas gracias por su atención!  ·  MCDI501 · Grupo 6 (Fernanda Ovalle, César Lorca, Jorge Álvarez, Sebastián Cajales)</a:t>
+              <a:t>REPRODUCIBILIDAD Y CIERRE DEL PROYECTO</a:t>
+            </a:r>
+          </a:p>
+          <a:p>
+            <a:pPr>
+              <a:spcBef>
+                <a:spcPts val="1000"/>
+              </a:spcBef>
+              <a:defRPr sz="2800" b="1">
+                <a:solidFill>
+                  <a:srgbClr val="FFFFFF"/>
+                </a:solidFill>
+              </a:defRPr>
+            </a:pPr>
+            <a:r>
+              <a:t>Trazabilidad Integral y Repositorio Oficial en GitHub</a:t>
+            </a:r>
+          </a:p>
+          <a:p>
+            <a:pPr>
+              <a:spcBef>
+                <a:spcPts val="1600"/>
+              </a:spcBef>
+              <a:defRPr sz="1800" b="1">
+                <a:solidFill>
+                  <a:srgbClr val="60A5FA"/>
+                </a:solidFill>
+              </a:defRPr>
+            </a:pPr>
+            <a:r>
+              <a:t>https://github.com/jaossandon/sumativa1-f2-mcdi501</a:t>
+            </a:r>
+          </a:p>
+          <a:p>
+            <a:pPr>
+              <a:spcBef>
+                <a:spcPts val="1800"/>
+              </a:spcBef>
+              <a:defRPr sz="1300">
+                <a:solidFill>
+                  <a:srgbClr val="E2E8F0"/>
+                </a:solidFill>
+              </a:defRPr>
+            </a:pPr>
+            <a:r>
+              <a:t>• S1/: Exploración de datos y primer informe de calidad.</a:t>
+            </a:r>
+            <a:br/>
+            <a:r>
+              <a:t>• S2/: Remuestreo Bootstrap, Monte Carlo y Jackknife por universidad.</a:t>
+            </a:r>
+            <a:br/>
+            <a:r>
+              <a:t>• S3/: Notebooks reproducibles de Preparación, Regresión Logística e Impacto de Imputación (S3_01, S3_02, S3_03).</a:t>
+            </a:r>
+            <a:br/>
+            <a:r>
+              <a:t>• Resultados auditados y figuras de alta resolución integradas en plantilla institucional.</a:t>
+            </a:r>
+          </a:p>
+          <a:p>
+            <a:pPr>
+              <a:spcBef>
+                <a:spcPts val="2400"/>
+              </a:spcBef>
+              <a:defRPr sz="1400" b="1">
+                <a:solidFill>
+                  <a:srgbClr val="FDE047"/>
+                </a:solidFill>
+              </a:defRPr>
+            </a:pPr>
+            <a:r>
+              <a:t>¡Muchas gracias! — Grupo 6 (Fernanda Ovalle, Sebastián Cajales, César Lorca, Jorge Álvarez)</a:t>
             </a:r>
           </a:p>
         </p:txBody>

</xml_diff>